<commit_message>
Add Demo 2 & 3 handouts and update presentation
Co-Authored-By: Claude Sonnet 4.6 <noreply@anthropic.com>
</commit_message>
<xml_diff>
--- a/Agentic Coding.pptx
+++ b/Agentic Coding.pptx
@@ -687,7 +687,19 @@
       </p:grpSpPr>
       <p:sp>
         <p:nvSpPr>
-          <p:cNvPr id="2" name="Notes Placeholder 1"/>
+          <p:cNvPr id="2" name="Slide Image Placeholder 1"/>
+          <p:cNvSpPr>
+            <a:spLocks noGrp="1" noRot="1" noChangeAspect="1"/>
+          </p:cNvSpPr>
+          <p:nvPr>
+            <p:ph type="sldImg"/>
+          </p:nvPr>
+        </p:nvSpPr>
+        <p:spPr/>
+      </p:sp>
+      <p:sp>
+        <p:nvSpPr>
+          <p:cNvPr id="3" name="Notes Placeholder 2"/>
           <p:cNvSpPr>
             <a:spLocks noGrp="1"/>
           </p:cNvSpPr>
@@ -700,14 +712,39 @@
           <a:bodyPr/>
           <a:lstStyle/>
           <a:p>
-            <a:r>
-              <a:rPr lang="en-US" dirty="0"/>
-              <a:t>Section divider. Seventeen minutes , the workshop's second-highest-leverage moment. This is the workflow they'll use for every real task. Includes the Superpowers segment as the production-grade version.</a:t>
-            </a:r>
+            <a:endParaRPr lang="en-US" dirty="0"/>
+          </a:p>
+        </p:txBody>
+      </p:sp>
+      <p:sp>
+        <p:nvSpPr>
+          <p:cNvPr id="4" name="Slide Number Placeholder 3"/>
+          <p:cNvSpPr>
+            <a:spLocks noGrp="1"/>
+          </p:cNvSpPr>
+          <p:nvPr>
+            <p:ph type="sldNum" sz="quarter" idx="5"/>
+          </p:nvPr>
+        </p:nvSpPr>
+        <p:spPr/>
+        <p:txBody>
+          <a:bodyPr/>
+          <a:lstStyle/>
+          <a:p>
+            <a:fld id="{C65E3571-8537-3947-BFEA-041D2F0B9B53}" type="slidenum">
+              <a:rPr lang="en-US" smtClean="0"/>
+              <a:t>13</a:t>
+            </a:fld>
+            <a:endParaRPr lang="en-US"/>
           </a:p>
         </p:txBody>
       </p:sp>
     </p:spTree>
+    <p:extLst>
+      <p:ext uri="{BB962C8B-B14F-4D97-AF65-F5344CB8AC3E}">
+        <p14:creationId xmlns:p14="http://schemas.microsoft.com/office/powerpoint/2010/main" val="1705873661"/>
+      </p:ext>
+    </p:extLst>
   </p:cSld>
   <p:clrMapOvr>
     <a:masterClrMapping/>
@@ -749,7 +786,7 @@
           <a:p>
             <a:r>
               <a:rPr lang="en-US" dirty="0"/>
-              <a:t>Walk the loop. Critical point: when the output is wrong, fix the SPEC and regenerate , don't patch the code manually. Patching the code throws away the learning. The arrow goes back to the spec, not the generated code.</a:t>
+              <a:t>Section divider. Seventeen minutes , the workshop's second-highest-leverage moment. This is the workflow they'll use for every real task. Includes the Superpowers segment as the production-grade version.</a:t>
             </a:r>
           </a:p>
         </p:txBody>
@@ -796,7 +833,7 @@
           <a:p>
             <a:r>
               <a:rPr lang="en-US" dirty="0"/>
-              <a:t>Five sections, always. Reference existing files , it's the cheat code. 'Follow the pattern in userService.js' is worth a paragraph of description. 'Out of scope' is the brake that stops the AI rewriting half your project. Success criteria double as your review checklist , you already know what you're checking for.</a:t>
+              <a:t>Walk the loop. Critical point: when the output is wrong, fix the SPEC and regenerate , don't patch the code manually. Patching the code throws away the learning. The arrow goes back to the spec, not the generated code.</a:t>
             </a:r>
           </a:p>
         </p:txBody>
@@ -843,7 +880,7 @@
           <a:p>
             <a:r>
               <a:rPr lang="en-US" dirty="0"/>
-              <a:t>Why review is non-negotiable. AI confidently generates plausible-looking wrong code. It hallucinates function names, imports libraries that don't exist, follows the conventions it thinks you want , not the ones you actually have. A 30-second diff catches 90% of the problems. Light touch on 'agents as markdown' here if time permits , an agent in this ecosystem is often just a markdown file defining a role plus tools plus focus. Don't go deep.</a:t>
+              <a:t>Five sections, always. Reference existing files , it's the cheat code. 'Follow the pattern in userService.js' is worth a paragraph of description. 'Out of scope' is the brake that stops the AI rewriting half your project. Success criteria double as your review checklist , you already know what you're checking for.</a:t>
             </a:r>
           </a:p>
         </p:txBody>
@@ -890,7 +927,7 @@
           <a:p>
             <a:r>
               <a:rPr lang="en-US" dirty="0"/>
-              <a:t>Frame Superpowers as the production version of everything you just taught. Free, open-source, ~175k stars, accepted into the Anthropic Claude Code marketplace January 2026, now natively supports 8+ hosts (Claude Code, Cursor, Codex CLI/App, Gemini CLI, OpenCode, Copilot CLI, Factory Droid). Tell them: the discipline you just learned isn't your opinion , it's what the most-starred plugin in the ecosystem enforces by default.</a:t>
+              <a:t>Why review is non-negotiable. AI confidently generates plausible-looking wrong code. It hallucinates function names, imports libraries that don't exist, follows the conventions it thinks you want , not the ones you actually have. A 30-second diff catches 90% of the problems. Light touch on 'agents as markdown' here if time permits , an agent in this ecosystem is often just a markdown file defining a role plus tools plus focus. Don't go deep.</a:t>
             </a:r>
           </a:p>
         </p:txBody>
@@ -937,7 +974,7 @@
           <a:p>
             <a:r>
               <a:rPr lang="en-US" dirty="0"/>
-              <a:t>Walk the skills table. No slash commands needed , say 'let's build X' and brainstorming fires before Claude writes a line. Your CLAUDE.md always wins. Tell the dashboard story (real user report): a developer asked Claude+Superpowers to 'add a dashboard for user analytics.' Instead of generating code, brainstorming activated and asked about brand identity, layout priorities, and UI patterns. Only after the spec was nailed did writing-plans run, then subagent-driven-development executed task-by-task with code review between each. That's the whole 'spec → generate → review' idea, automated. Then run Demo #3: full Superpowers flow on a real bug. Cut at 6 minutes , narrate that in a real session this continues to completion. When NOT to use it: quick scripts, exploring unfamiliar APIs, one-line fixes. Install: /plugin install superpowers@claude-plugins-official.</a:t>
+              <a:t>Frame Superpowers as the production version of everything you just taught. Free, open-source, ~175k stars, accepted into the Anthropic Claude Code marketplace January 2026, now natively supports 8+ hosts (Claude Code, Cursor, Codex CLI/App, Gemini CLI, OpenCode, Copilot CLI, Factory Droid). Tell them: the discipline you just learned isn't your opinion , it's what the most-starred plugin in the ecosystem enforces by default.</a:t>
             </a:r>
           </a:p>
         </p:txBody>
@@ -984,7 +1021,7 @@
           <a:p>
             <a:r>
               <a:rPr lang="en-US" dirty="0"/>
-              <a:t>Walk the assignment. Use whichever filename your tool expects , the concept is the same everywhere. Graded on the process, not the fix. A broken result with a good spec and a visible review beats a working fix from 'fix it.' Show where ISSUES.md and FEATURES.md live in the repo. Mention any submission/sharing channel (Discord, email).</a:t>
+              <a:t>Walk the skills table. No slash commands needed , say 'let's build X' and brainstorming fires before Claude writes a line. Your CLAUDE.md always wins. Tell the dashboard story (real user report): a developer asked Claude+Superpowers to 'add a dashboard for user analytics.' Instead of generating code, brainstorming activated and asked about brand identity, layout priorities, and UI patterns. Only after the spec was nailed did writing-plans run, then subagent-driven-development executed task-by-task with code review between each. That's the whole 'spec → generate → review' idea, automated. Then run Demo #3: full Superpowers flow on a real bug. Cut at 6 minutes , narrate that in a real session this continues to completion. When NOT to use it: quick scripts, exploring unfamiliar APIs, one-line fixes. Install: /plugin install superpowers@claude-plugins-official.</a:t>
             </a:r>
           </a:p>
         </p:txBody>
@@ -1031,7 +1068,7 @@
           <a:p>
             <a:r>
               <a:rPr lang="en-US" dirty="0"/>
-              <a:t>Closing line: 'The discipline matters more than the tool. If you learn the loop , spec, generate, review , you can move between Cursor, Claude, Copilot, or whatever comes next without losing your footing.' Then take questions. Likely Q's: which tool to use (whatever your team uses), does it work for X language (yes , language-agnostic), cost (free tiers fine for learning), Copilot autocomplete vs agentic (different jobs, complementary), AI replacing programmers (no, but those who use it will outpace those who don't), should I install Superpowers now (only if on Claude Code and ready for structured workflow), can I write my own skills (yes , markdown + YAML frontmatter; the writing-skills skill guides you).</a:t>
+              <a:t>Walk the assignment. Use whichever filename your tool expects , the concept is the same everywhere. Graded on the process, not the fix. A broken result with a good spec and a visible review beats a working fix from 'fix it.' Show where ISSUES.md and FEATURES.md live in the repo. Mention any submission/sharing channel (Discord, email).</a:t>
             </a:r>
           </a:p>
         </p:txBody>
@@ -1079,6 +1116,53 @@
             <a:r>
               <a:rPr lang="en-US" dirty="0"/>
               <a:t>Set expectations. Concrete deliverables: a real CLAUDE.md you generated, one full spec→generate→review cycle, the five principles, and a practice repo to keep. Don't promise mastery , promise muscle memory.</a:t>
+            </a:r>
+          </a:p>
+        </p:txBody>
+      </p:sp>
+    </p:spTree>
+  </p:cSld>
+  <p:clrMapOvr>
+    <a:masterClrMapping/>
+  </p:clrMapOvr>
+</p:notes>
+</file>
+
+<file path=ppt/notesSlides/notesSlide20.xml><?xml version="1.0" encoding="utf-8"?>
+<p:notes xmlns:a="http://schemas.openxmlformats.org/drawingml/2006/main" xmlns:r="http://schemas.openxmlformats.org/officeDocument/2006/relationships" xmlns:p="http://schemas.openxmlformats.org/presentationml/2006/main">
+  <p:cSld>
+    <p:spTree>
+      <p:nvGrpSpPr>
+        <p:cNvPr id="1" name=""/>
+        <p:cNvGrpSpPr/>
+        <p:nvPr/>
+      </p:nvGrpSpPr>
+      <p:grpSpPr>
+        <a:xfrm>
+          <a:off x="0" y="0"/>
+          <a:ext cx="0" cy="0"/>
+          <a:chOff x="0" y="0"/>
+          <a:chExt cx="0" cy="0"/>
+        </a:xfrm>
+      </p:grpSpPr>
+      <p:sp>
+        <p:nvSpPr>
+          <p:cNvPr id="2" name="Notes Placeholder 1"/>
+          <p:cNvSpPr>
+            <a:spLocks noGrp="1"/>
+          </p:cNvSpPr>
+          <p:nvPr>
+            <p:ph type="body" idx="1"/>
+          </p:nvPr>
+        </p:nvSpPr>
+        <p:spPr/>
+        <p:txBody>
+          <a:bodyPr/>
+          <a:lstStyle/>
+          <a:p>
+            <a:r>
+              <a:rPr lang="en-US" dirty="0"/>
+              <a:t>Closing line: 'The discipline matters more than the tool. If you learn the loop , spec, generate, review , you can move between Cursor, Claude, Copilot, or whatever comes next without losing your footing.' Then take questions. Likely Q's: which tool to use (whatever your team uses), does it work for X language (yes , language-agnostic), cost (free tiers fine for learning), Copilot autocomplete vs agentic (different jobs, complementary), AI replacing programmers (no, but those who use it will outpace those who don't), should I install Superpowers now (only if on Claude Code and ready for structured workflow), can I write my own skills (yes , markdown + YAML frontmatter; the writing-skills skill guides you).</a:t>
             </a:r>
           </a:p>
         </p:txBody>
@@ -5006,12 +5090,12 @@
           <a:p>
             <a:pPr algn="l"/>
             <a:r>
-              <a:rPr lang="en-US" sz="2000">
+              <a:rPr lang="en-US" sz="2000" dirty="0">
                 <a:solidFill>
                   <a:srgbClr val="1F2937"/>
                 </a:solidFill>
               </a:rPr>
-              <a:t>You re-explain the stack, the conventions, the gotchas, every time.</a:t>
+              <a:t>You re-explain the stack, the conventions, the pitfalls, every time.</a:t>
             </a:r>
           </a:p>
         </p:txBody>
@@ -5221,28 +5305,36 @@
         <p:spPr>
           <a:xfrm>
             <a:off x="1066800" y="3784600"/>
-            <a:ext cx="4572000" cy="646331"/>
-          </a:xfrm>
-          <a:prstGeom prst="rect">
-            <a:avLst/>
-          </a:prstGeom>
-          <a:noFill/>
-        </p:spPr>
-        <p:txBody>
-          <a:bodyPr vertOverflow="overflow" vert="horz" wrap="square" rtlCol="0" anchor="t">
-            <a:spAutoFit/>
-          </a:bodyPr>
-          <a:lstStyle/>
-          <a:p>
-            <a:pPr algn="l"/>
-            <a:r>
-              <a:rPr lang="en-US">
+            <a:ext cx="4572000" cy="369332"/>
+          </a:xfrm>
+          <a:prstGeom prst="rect">
+            <a:avLst/>
+          </a:prstGeom>
+          <a:noFill/>
+        </p:spPr>
+        <p:txBody>
+          <a:bodyPr vertOverflow="overflow" vert="horz" wrap="square" rtlCol="0" anchor="t">
+            <a:spAutoFit/>
+          </a:bodyPr>
+          <a:lstStyle/>
+          <a:p>
+            <a:r>
+              <a:rPr lang="en-US" dirty="0">
                 <a:solidFill>
                   <a:srgbClr val="0E1116"/>
                 </a:solidFill>
               </a:rPr>
-              <a:t>·  AI guesses your stack, your style, your gotchas</a:t>
-            </a:r>
+              <a:t>·  AI guesses your stack, your style, your </a:t>
+            </a:r>
+            <a:r>
+              <a:rPr lang="en-AU" dirty="0"/>
+              <a:t>pitfalls</a:t>
+            </a:r>
+            <a:endParaRPr lang="en-US" dirty="0">
+              <a:solidFill>
+                <a:srgbClr val="0E1116"/>
+              </a:solidFill>
+            </a:endParaRPr>
           </a:p>
         </p:txBody>
       </p:sp>
@@ -5301,27 +5393,27 @@
         <p:spPr>
           <a:xfrm>
             <a:off x="1066800" y="4851400"/>
-            <a:ext cx="4572000" cy="646331"/>
-          </a:xfrm>
-          <a:prstGeom prst="rect">
-            <a:avLst/>
-          </a:prstGeom>
-          <a:noFill/>
-        </p:spPr>
-        <p:txBody>
-          <a:bodyPr vertOverflow="overflow" vert="horz" wrap="square" rtlCol="0" anchor="t">
-            <a:spAutoFit/>
-          </a:bodyPr>
-          <a:lstStyle/>
-          <a:p>
-            <a:pPr algn="l"/>
-            <a:r>
-              <a:rPr lang="en-US">
+            <a:ext cx="4572000" cy="369332"/>
+          </a:xfrm>
+          <a:prstGeom prst="rect">
+            <a:avLst/>
+          </a:prstGeom>
+          <a:noFill/>
+        </p:spPr>
+        <p:txBody>
+          <a:bodyPr vertOverflow="overflow" vert="horz" wrap="square" rtlCol="0" anchor="t">
+            <a:spAutoFit/>
+          </a:bodyPr>
+          <a:lstStyle/>
+          <a:p>
+            <a:pPr algn="l"/>
+            <a:r>
+              <a:rPr lang="en-US" dirty="0">
                 <a:solidFill>
                   <a:srgbClr val="0E1116"/>
                 </a:solidFill>
               </a:rPr>
-              <a:t>·  You waste tokens explaining the same thing again</a:t>
+              <a:t>·  You waste tokens explaining the same thing</a:t>
             </a:r>
           </a:p>
         </p:txBody>
@@ -5794,11 +5886,17 @@
           <p:cNvGraphicFramePr>
             <a:graphicFrameLocks noGrp="1"/>
           </p:cNvGraphicFramePr>
-          <p:nvPr/>
+          <p:nvPr>
+            <p:extLst>
+              <p:ext uri="{D42A27DB-BD31-4B8C-83A1-F6EECF244321}">
+                <p14:modId xmlns:p14="http://schemas.microsoft.com/office/powerpoint/2010/main" val="1691475843"/>
+              </p:ext>
+            </p:extLst>
+          </p:nvPr>
         </p:nvGraphicFramePr>
         <p:xfrm>
           <a:off x="762000" y="1651000"/>
-          <a:ext cx="10668000" cy="4644560"/>
+          <a:ext cx="10668000" cy="3483420"/>
         </p:xfrm>
         <a:graphic>
           <a:graphicData uri="http://schemas.openxmlformats.org/drawingml/2006/table">
@@ -5910,7 +6008,7 @@
                     <a:p>
                       <a:pPr algn="l"/>
                       <a:r>
-                        <a:rPr lang="en-US" sz="1600">
+                        <a:rPr lang="en-US" sz="1600" dirty="0">
                           <a:solidFill>
                             <a:srgbClr val="0E1116"/>
                           </a:solidFill>
@@ -5946,12 +6044,28 @@
                     <a:p>
                       <a:pPr algn="l"/>
                       <a:r>
-                        <a:rPr lang="en-US" sz="1600">
+                        <a:rPr lang="en-US" sz="1600" dirty="0">
                           <a:solidFill>
                             <a:srgbClr val="0E1116"/>
                           </a:solidFill>
                         </a:rPr>
-                        <a:t>.claude/rules/</a:t>
+                        <a:t>.</a:t>
+                      </a:r>
+                      <a:r>
+                        <a:rPr lang="en-US" sz="1600" dirty="0" err="1">
+                          <a:solidFill>
+                            <a:srgbClr val="0E1116"/>
+                          </a:solidFill>
+                        </a:rPr>
+                        <a:t>claude</a:t>
+                      </a:r>
+                      <a:r>
+                        <a:rPr lang="en-US" sz="1600" dirty="0">
+                          <a:solidFill>
+                            <a:srgbClr val="0E1116"/>
+                          </a:solidFill>
+                        </a:rPr>
+                        <a:t>/rules/</a:t>
                       </a:r>
                     </a:p>
                   </a:txBody>
@@ -5988,8 +6102,16 @@
                     <a:lstStyle/>
                     <a:p>
                       <a:r>
-                        <a:rPr lang="en-US" sz="1400"/>
-                        <a:t>.cursor/rules/*.mdc · .cursorrules (legacy)</a:t>
+                        <a:rPr lang="en-US" sz="1400" dirty="0"/>
+                        <a:t>.cursor/rules/*.mdc · .</a:t>
+                      </a:r>
+                      <a:r>
+                        <a:rPr lang="en-US" sz="1400" dirty="0" err="1"/>
+                        <a:t>cursorrules</a:t>
+                      </a:r>
+                      <a:r>
+                        <a:rPr lang="en-US" sz="1400" dirty="0"/>
+                        <a:t> (legacy)</a:t>
                       </a:r>
                     </a:p>
                   </a:txBody>
@@ -6002,7 +6124,7 @@
                     <a:p>
                       <a:pPr algn="l"/>
                       <a:r>
-                        <a:rPr lang="en-US" sz="1600">
+                        <a:rPr lang="en-US" sz="1600" dirty="0">
                           <a:solidFill>
                             <a:srgbClr val="0E1116"/>
                           </a:solidFill>
@@ -6045,13 +6167,42 @@
                     <a:p>
                       <a:pPr algn="l"/>
                       <a:r>
-                        <a:rPr lang="en-US" sz="1600">
+                        <a:rPr lang="en-US" sz="1600" dirty="0">
                           <a:solidFill>
                             <a:srgbClr val="0E1116"/>
                           </a:solidFill>
                         </a:rPr>
-                        <a:t>.github/copilot-instructions.md</a:t>
+                        <a:t>.</a:t>
                       </a:r>
+                      <a:r>
+                        <a:rPr lang="en-US" sz="1600" dirty="0" err="1">
+                          <a:solidFill>
+                            <a:srgbClr val="0E1116"/>
+                          </a:solidFill>
+                        </a:rPr>
+                        <a:t>github</a:t>
+                      </a:r>
+                      <a:r>
+                        <a:rPr lang="en-US" sz="1600" dirty="0">
+                          <a:solidFill>
+                            <a:srgbClr val="0E1116"/>
+                          </a:solidFill>
+                        </a:rPr>
+                        <a:t>/copilot-</a:t>
+                      </a:r>
+                      <a:r>
+                        <a:rPr lang="en-US" sz="1600" dirty="0" err="1">
+                          <a:solidFill>
+                            <a:srgbClr val="0E1116"/>
+                          </a:solidFill>
+                        </a:rPr>
+                        <a:t>instructions.md</a:t>
+                      </a:r>
+                      <a:endParaRPr lang="en-US" sz="1600" dirty="0">
+                        <a:solidFill>
+                          <a:srgbClr val="0E1116"/>
+                        </a:solidFill>
+                      </a:endParaRPr>
                     </a:p>
                   </a:txBody>
                   <a:tcPr anchor="ctr"/>
@@ -6088,68 +6239,7 @@
                     <a:p>
                       <a:pPr algn="l"/>
                       <a:r>
-                        <a:rPr lang="en-US" sz="1600">
-                          <a:solidFill>
-                            <a:srgbClr val="0E1116"/>
-                          </a:solidFill>
-                        </a:rPr>
-                        <a:t>Windsurf</a:t>
-                      </a:r>
-                    </a:p>
-                  </a:txBody>
-                  <a:tcPr anchor="ctr"/>
-                </a:tc>
-                <a:tc>
-                  <a:txBody>
-                    <a:bodyPr/>
-                    <a:lstStyle/>
-                    <a:p>
-                      <a:pPr algn="l"/>
-                      <a:r>
-                        <a:rPr lang="en-US" sz="1600">
-                          <a:solidFill>
-                            <a:srgbClr val="0E1116"/>
-                          </a:solidFill>
-                        </a:rPr>
-                        <a:t>.windsurfrules</a:t>
-                      </a:r>
-                    </a:p>
-                  </a:txBody>
-                  <a:tcPr anchor="ctr"/>
-                </a:tc>
-                <a:tc>
-                  <a:txBody>
-                    <a:bodyPr/>
-                    <a:lstStyle/>
-                    <a:p>
-                      <a:pPr algn="l"/>
-                      <a:r>
-                        <a:rPr lang="en-US" sz="1600">
-                          <a:solidFill>
-                            <a:srgbClr val="0E1116"/>
-                          </a:solidFill>
-                        </a:rPr>
-                        <a:t>.windsurf/rules/</a:t>
-                      </a:r>
-                    </a:p>
-                  </a:txBody>
-                  <a:tcPr anchor="ctr"/>
-                </a:tc>
-                <a:extLst>
-                  <a:ext uri="{0D108BD9-81ED-4DB2-BD59-A6C34878D82A}">
-                    <a16:rowId xmlns:a16="http://schemas.microsoft.com/office/drawing/2014/main" val="1770864717"/>
-                  </a:ext>
-                </a:extLst>
-              </a:tr>
-              <a:tr h="580570">
-                <a:tc>
-                  <a:txBody>
-                    <a:bodyPr/>
-                    <a:lstStyle/>
-                    <a:p>
-                      <a:pPr algn="l"/>
-                      <a:r>
-                        <a:rPr lang="en-US" sz="1600">
+                        <a:rPr lang="en-US" sz="1600" dirty="0">
                           <a:solidFill>
                             <a:srgbClr val="0E1116"/>
                           </a:solidFill>
@@ -6185,7 +6275,7 @@
                     <a:p>
                       <a:pPr algn="l"/>
                       <a:r>
-                        <a:rPr lang="en-US" sz="1600">
+                        <a:rPr lang="en-US" sz="1600" dirty="0">
                           <a:solidFill>
                             <a:srgbClr val="0E1116"/>
                           </a:solidFill>
@@ -6208,74 +6298,21 @@
                     <a:bodyPr/>
                     <a:lstStyle/>
                     <a:p>
-                      <a:pPr algn="l"/>
                       <a:r>
-                        <a:rPr lang="en-US" sz="1600">
-                          <a:solidFill>
-                            <a:srgbClr val="0E1116"/>
-                          </a:solidFill>
-                        </a:rPr>
-                        <a:t>Aider</a:t>
-                      </a:r>
-                    </a:p>
-                  </a:txBody>
-                  <a:tcPr anchor="ctr"/>
-                </a:tc>
-                <a:tc>
-                  <a:txBody>
-                    <a:bodyPr/>
-                    <a:lstStyle/>
-                    <a:p>
-                      <a:pPr algn="l"/>
-                      <a:r>
-                        <a:rPr lang="en-US" sz="1600">
-                          <a:solidFill>
-                            <a:srgbClr val="0E1116"/>
-                          </a:solidFill>
-                        </a:rPr>
-                        <a:t>CONVENTIONS.md</a:t>
-                      </a:r>
-                    </a:p>
-                  </a:txBody>
-                  <a:tcPr anchor="ctr"/>
-                </a:tc>
-                <a:tc>
-                  <a:txBody>
-                    <a:bodyPr/>
-                    <a:lstStyle/>
-                    <a:p>
-                      <a:pPr algn="l"/>
-                      <a:r>
-                        <a:rPr lang="en-US" sz="1600">
-                          <a:solidFill>
-                            <a:srgbClr val="0E1116"/>
-                          </a:solidFill>
-                        </a:rPr>
-                        <a:t>-</a:t>
-                      </a:r>
-                    </a:p>
-                  </a:txBody>
-                  <a:tcPr anchor="ctr"/>
-                </a:tc>
-                <a:extLst>
-                  <a:ext uri="{0D108BD9-81ED-4DB2-BD59-A6C34878D82A}">
-                    <a16:rowId xmlns:a16="http://schemas.microsoft.com/office/drawing/2014/main" val="3180048903"/>
-                  </a:ext>
-                </a:extLst>
-              </a:tr>
-              <a:tr h="580570">
-                <a:tc>
-                  <a:txBody>
-                    <a:bodyPr/>
-                    <a:lstStyle/>
-                    <a:p>
-                      <a:r>
-                        <a:rPr lang="en-US" sz="1400" b="1">
+                        <a:rPr lang="en-US" sz="1400" b="1" dirty="0" err="1">
                           <a:solidFill>
                             <a:srgbClr val="FFFFFF"/>
                           </a:solidFill>
                         </a:rPr>
-                        <a:t>AGENTS.md · cross-tool standard</a:t>
+                        <a:t>AGENTS.md</a:t>
+                      </a:r>
+                      <a:r>
+                        <a:rPr lang="en-US" sz="1400" b="1" dirty="0">
+                          <a:solidFill>
+                            <a:srgbClr val="FFFFFF"/>
+                          </a:solidFill>
+                        </a:rPr>
+                        <a:t> · cross-tool standard</a:t>
                       </a:r>
                     </a:p>
                   </a:txBody>
@@ -6312,7 +6349,7 @@
                     <a:lstStyle/>
                     <a:p>
                       <a:r>
-                        <a:rPr lang="en-US" sz="1400" b="1">
+                        <a:rPr lang="en-US" sz="1400" b="1" dirty="0">
                           <a:solidFill>
                             <a:srgbClr val="FFFFFF"/>
                           </a:solidFill>
@@ -6351,7 +6388,7 @@
         </p:nvSpPr>
         <p:spPr>
           <a:xfrm>
-            <a:off x="762000" y="5969000"/>
+            <a:off x="762000" y="5825123"/>
             <a:ext cx="10668000" cy="338554"/>
           </a:xfrm>
           <a:prstGeom prst="rect">
@@ -6367,7 +6404,7 @@
           <a:p>
             <a:pPr algn="l"/>
             <a:r>
-              <a:rPr lang="en-US" sz="1600" i="1">
+              <a:rPr lang="en-US" sz="1600" i="1" dirty="0">
                 <a:solidFill>
                   <a:srgbClr val="1F2937"/>
                 </a:solidFill>
@@ -7398,9 +7435,9 @@
           </a:bodyPr>
           <a:lstStyle/>
           <a:p>
-            <a:pPr algn="l"/>
-            <a:r>
-              <a:rPr lang="en-US" sz="1200" b="1">
+            <a:pPr algn="ctr"/>
+            <a:r>
+              <a:rPr lang="en-US" sz="1200" b="1" dirty="0">
                 <a:solidFill>
                   <a:srgbClr val="FAFAFA"/>
                 </a:solidFill>
@@ -7820,13 +7857,69 @@
           <a:p>
             <a:pPr algn="l"/>
             <a:r>
-              <a:rPr lang="en-US" sz="1400" b="1">
-                <a:solidFill>
-                  <a:srgbClr val="0E1116"/>
-                </a:solidFill>
-              </a:rPr>
-              <a:t>Only Claude Code needs the symlink. Cursor, Copilot, Antigravity, Windsurf, and Aider read AGENTS.md natively. Don't copy-paste the same content into two files. One will become outdated, and that's the one your AI will read.</a:t>
-            </a:r>
+              <a:rPr lang="en-US" sz="1400" dirty="0">
+                <a:solidFill>
+                  <a:schemeClr val="bg1"/>
+                </a:solidFill>
+              </a:rPr>
+              <a:t># </a:t>
+            </a:r>
+            <a:r>
+              <a:rPr lang="en-US" sz="1400" dirty="0" err="1">
+                <a:solidFill>
+                  <a:schemeClr val="bg1"/>
+                </a:solidFill>
+              </a:rPr>
+              <a:t>AGENTS.md</a:t>
+            </a:r>
+            <a:r>
+              <a:rPr lang="en-US" sz="1400" dirty="0">
+                <a:solidFill>
+                  <a:schemeClr val="bg1"/>
+                </a:solidFill>
+              </a:rPr>
+              <a:t> is the source of truth</a:t>
+            </a:r>
+          </a:p>
+          <a:p>
+            <a:pPr algn="l"/>
+            <a:r>
+              <a:rPr lang="en-US" sz="1400" dirty="0">
+                <a:solidFill>
+                  <a:schemeClr val="bg1"/>
+                </a:solidFill>
+              </a:rPr>
+              <a:t>ln -s </a:t>
+            </a:r>
+            <a:r>
+              <a:rPr lang="en-US" sz="1400" dirty="0" err="1">
+                <a:solidFill>
+                  <a:schemeClr val="bg1"/>
+                </a:solidFill>
+              </a:rPr>
+              <a:t>AGENTS.md</a:t>
+            </a:r>
+            <a:r>
+              <a:rPr lang="en-US" sz="1400" dirty="0">
+                <a:solidFill>
+                  <a:schemeClr val="bg1"/>
+                </a:solidFill>
+              </a:rPr>
+              <a:t> </a:t>
+            </a:r>
+            <a:r>
+              <a:rPr lang="en-US" sz="1400" dirty="0" err="1">
+                <a:solidFill>
+                  <a:schemeClr val="bg1"/>
+                </a:solidFill>
+              </a:rPr>
+              <a:t>CLAUDE.md</a:t>
+            </a:r>
+            <a:endParaRPr lang="en-US" sz="1400" dirty="0">
+              <a:solidFill>
+                <a:schemeClr val="bg1"/>
+              </a:solidFill>
+            </a:endParaRPr>
           </a:p>
         </p:txBody>
       </p:sp>
@@ -8090,17 +8183,77 @@
           <a:p>
             <a:pPr algn="l"/>
             <a:r>
-              <a:rPr lang="en-US" sz="1400">
+              <a:rPr lang="en-US" sz="1400" dirty="0">
                 <a:solidFill>
                   <a:srgbClr val="FAFAFA"/>
                 </a:solidFill>
                 <a:latin typeface="Consolas"/>
                 <a:cs typeface="Consolas"/>
               </a:rPr>
-              <a:t># CLAUDE.md
-@AGENTS.md
+              <a:t># </a:t>
+            </a:r>
+            <a:r>
+              <a:rPr lang="en-US" sz="1400" dirty="0" err="1">
+                <a:solidFill>
+                  <a:srgbClr val="FAFAFA"/>
+                </a:solidFill>
+                <a:latin typeface="Consolas"/>
+                <a:cs typeface="Consolas"/>
+              </a:rPr>
+              <a:t>CLAUDE.md</a:t>
+            </a:r>
+            <a:r>
+              <a:rPr lang="en-US" sz="1400" dirty="0">
+                <a:solidFill>
+                  <a:srgbClr val="FAFAFA"/>
+                </a:solidFill>
+                <a:latin typeface="Consolas"/>
+                <a:cs typeface="Consolas"/>
+              </a:rPr>
+              <a:t>
+@</a:t>
+            </a:r>
+            <a:r>
+              <a:rPr lang="en-US" sz="1400" dirty="0" err="1">
+                <a:solidFill>
+                  <a:srgbClr val="FAFAFA"/>
+                </a:solidFill>
+                <a:latin typeface="Consolas"/>
+                <a:cs typeface="Consolas"/>
+              </a:rPr>
+              <a:t>AGENTS.md</a:t>
+            </a:r>
+            <a:r>
+              <a:rPr lang="en-US" sz="1400" dirty="0">
+                <a:solidFill>
+                  <a:srgbClr val="FAFAFA"/>
+                </a:solidFill>
+                <a:latin typeface="Consolas"/>
+                <a:cs typeface="Consolas"/>
+              </a:rPr>
+              <a:t>
 # or just plain text:
-See AGENTS.md for project context.</a:t>
+See </a:t>
+            </a:r>
+            <a:r>
+              <a:rPr lang="en-US" sz="1400" dirty="0" err="1">
+                <a:solidFill>
+                  <a:srgbClr val="FAFAFA"/>
+                </a:solidFill>
+                <a:latin typeface="Consolas"/>
+                <a:cs typeface="Consolas"/>
+              </a:rPr>
+              <a:t>AGENTS.md</a:t>
+            </a:r>
+            <a:r>
+              <a:rPr lang="en-US" sz="1400" dirty="0">
+                <a:solidFill>
+                  <a:srgbClr val="FAFAFA"/>
+                </a:solidFill>
+                <a:latin typeface="Consolas"/>
+                <a:cs typeface="Consolas"/>
+              </a:rPr>
+              <a:t> for project context.</a:t>
             </a:r>
           </a:p>
         </p:txBody>
@@ -8175,28 +8328,60 @@
         </p:nvSpPr>
         <p:spPr>
           <a:xfrm>
-            <a:off x="1016000" y="5867400"/>
-            <a:ext cx="10160000" cy="523220"/>
-          </a:xfrm>
-          <a:prstGeom prst="rect">
-            <a:avLst/>
-          </a:prstGeom>
-          <a:noFill/>
-        </p:spPr>
-        <p:txBody>
-          <a:bodyPr vertOverflow="overflow" vert="horz" wrap="square" rtlCol="0" anchor="t">
-            <a:spAutoFit/>
-          </a:bodyPr>
-          <a:lstStyle/>
-          <a:p>
-            <a:pPr algn="l"/>
-            <a:r>
-              <a:rPr lang="en-US" sz="1400" b="1">
+            <a:off x="888999" y="5782179"/>
+            <a:ext cx="10456333" cy="523220"/>
+          </a:xfrm>
+          <a:prstGeom prst="rect">
+            <a:avLst/>
+          </a:prstGeom>
+          <a:noFill/>
+        </p:spPr>
+        <p:txBody>
+          <a:bodyPr vertOverflow="overflow" vert="horz" wrap="square" rtlCol="0" anchor="t">
+            <a:spAutoFit/>
+          </a:bodyPr>
+          <a:lstStyle/>
+          <a:p>
+            <a:pPr algn="l"/>
+            <a:r>
+              <a:rPr lang="en-US" sz="1400" b="1" dirty="0">
                 <a:solidFill>
                   <a:srgbClr val="0E1116"/>
                 </a:solidFill>
               </a:rPr>
-              <a:t>Only Claude Code needs the symlink. Cursor, Copilot, Antigravity, Windsurf, and Aider read AGENTS.md natively. Don't copy-paste; one file will go stale.</a:t>
+              <a:t>Only Claude Code needs the </a:t>
+            </a:r>
+            <a:r>
+              <a:rPr lang="en-US" sz="1400" b="1" dirty="0" err="1">
+                <a:solidFill>
+                  <a:srgbClr val="0E1116"/>
+                </a:solidFill>
+              </a:rPr>
+              <a:t>symlink</a:t>
+            </a:r>
+            <a:r>
+              <a:rPr lang="en-US" sz="1400" b="1" dirty="0">
+                <a:solidFill>
+                  <a:srgbClr val="0E1116"/>
+                </a:solidFill>
+              </a:rPr>
+              <a:t>. Cursor, Copilot, Antigravity, Windsurf, and Aider read </a:t>
+            </a:r>
+            <a:r>
+              <a:rPr lang="en-US" sz="1400" b="1" dirty="0" err="1">
+                <a:solidFill>
+                  <a:srgbClr val="0E1116"/>
+                </a:solidFill>
+              </a:rPr>
+              <a:t>AGENTS.md</a:t>
+            </a:r>
+            <a:r>
+              <a:rPr lang="en-US" sz="1400" b="1" dirty="0">
+                <a:solidFill>
+                  <a:srgbClr val="0E1116"/>
+                </a:solidFill>
+              </a:rPr>
+              <a:t> natively. Don't copy-paste; one file will go stale.</a:t>
             </a:r>
           </a:p>
         </p:txBody>
@@ -8527,7 +8712,7 @@
           <a:p>
             <a:pPr algn="l"/>
             <a:r>
-              <a:rPr lang="en-US" sz="3200" b="1"/>
+              <a:rPr lang="en-US" sz="3200" b="1" dirty="0"/>
               <a:t>Three steps. One feedback path.</a:t>
             </a:r>
           </a:p>
@@ -9684,7 +9869,7 @@
         </p:nvSpPr>
         <p:spPr>
           <a:xfrm>
-            <a:off x="7239000" y="2209800"/>
+            <a:off x="7239000" y="2187222"/>
             <a:ext cx="4318000" cy="338554"/>
           </a:xfrm>
           <a:prstGeom prst="rect">
@@ -9700,7 +9885,7 @@
           <a:p>
             <a:pPr algn="l"/>
             <a:r>
-              <a:rPr lang="en-US" sz="1600">
+              <a:rPr lang="en-US" sz="1600" dirty="0">
                 <a:solidFill>
                   <a:srgbClr val="1F2937"/>
                 </a:solidFill>
@@ -9814,7 +9999,7 @@
         </p:nvSpPr>
         <p:spPr>
           <a:xfrm>
-            <a:off x="7239000" y="3606800"/>
+            <a:off x="7239000" y="3561644"/>
             <a:ext cx="4318000" cy="338554"/>
           </a:xfrm>
           <a:prstGeom prst="rect">
@@ -9830,7 +10015,7 @@
           <a:p>
             <a:pPr algn="l"/>
             <a:r>
-              <a:rPr lang="en-US" sz="1600">
+              <a:rPr lang="en-US" sz="1600" dirty="0">
                 <a:solidFill>
                   <a:srgbClr val="1F2937"/>
                 </a:solidFill>
@@ -9944,7 +10129,7 @@
         </p:nvSpPr>
         <p:spPr>
           <a:xfrm>
-            <a:off x="7239000" y="5003800"/>
+            <a:off x="7239000" y="5252158"/>
             <a:ext cx="4318000" cy="338554"/>
           </a:xfrm>
           <a:prstGeom prst="rect">
@@ -9960,7 +10145,7 @@
           <a:p>
             <a:pPr algn="l"/>
             <a:r>
-              <a:rPr lang="en-US" sz="1600">
+              <a:rPr lang="en-US" sz="1600" dirty="0">
                 <a:solidFill>
                   <a:srgbClr val="1F2937"/>
                 </a:solidFill>
@@ -10110,8 +10295,8 @@
           <a:p>
             <a:pPr algn="l"/>
             <a:r>
-              <a:rPr lang="en-US" sz="3600" b="1"/>
-              <a:t>AI writes wrong code that looks correct — confidently.</a:t>
+              <a:rPr lang="en-US" sz="3600" b="1" dirty="0"/>
+              <a:t>AI writes wrong code that looks correct - confidently.</a:t>
             </a:r>
           </a:p>
         </p:txBody>
@@ -10130,7 +10315,7 @@
         </p:nvSpPr>
         <p:spPr>
           <a:xfrm>
-            <a:off x="762000" y="3556000"/>
+            <a:off x="762000" y="2675467"/>
             <a:ext cx="3302000" cy="2222500"/>
           </a:xfrm>
           <a:prstGeom prst="rect">
@@ -10186,7 +10371,7 @@
         </p:nvSpPr>
         <p:spPr>
           <a:xfrm>
-            <a:off x="990600" y="3784600"/>
+            <a:off x="990600" y="2904067"/>
             <a:ext cx="2921000" cy="384721"/>
           </a:xfrm>
           <a:prstGeom prst="rect">
@@ -10222,7 +10407,7 @@
         </p:nvSpPr>
         <p:spPr>
           <a:xfrm>
-            <a:off x="990600" y="4572000"/>
+            <a:off x="990600" y="3691467"/>
             <a:ext cx="2921000" cy="584775"/>
           </a:xfrm>
           <a:prstGeom prst="rect">
@@ -10262,7 +10447,7 @@
         </p:nvSpPr>
         <p:spPr>
           <a:xfrm>
-            <a:off x="4318000" y="3556000"/>
+            <a:off x="4318000" y="2675467"/>
             <a:ext cx="3302000" cy="2222500"/>
           </a:xfrm>
           <a:prstGeom prst="rect">
@@ -10318,7 +10503,7 @@
         </p:nvSpPr>
         <p:spPr>
           <a:xfrm>
-            <a:off x="4546600" y="3784600"/>
+            <a:off x="4546600" y="2904067"/>
             <a:ext cx="2921000" cy="384721"/>
           </a:xfrm>
           <a:prstGeom prst="rect">
@@ -10354,7 +10539,7 @@
         </p:nvSpPr>
         <p:spPr>
           <a:xfrm>
-            <a:off x="4546600" y="4572000"/>
+            <a:off x="4546600" y="3691467"/>
             <a:ext cx="2921000" cy="584775"/>
           </a:xfrm>
           <a:prstGeom prst="rect">
@@ -10394,7 +10579,7 @@
         </p:nvSpPr>
         <p:spPr>
           <a:xfrm>
-            <a:off x="7874000" y="3556000"/>
+            <a:off x="7874000" y="2675467"/>
             <a:ext cx="3302000" cy="2222500"/>
           </a:xfrm>
           <a:prstGeom prst="rect">
@@ -10450,7 +10635,7 @@
         </p:nvSpPr>
         <p:spPr>
           <a:xfrm>
-            <a:off x="8102600" y="3784600"/>
+            <a:off x="8102600" y="2904067"/>
             <a:ext cx="2921000" cy="384721"/>
           </a:xfrm>
           <a:prstGeom prst="rect">
@@ -10486,7 +10671,7 @@
         </p:nvSpPr>
         <p:spPr>
           <a:xfrm>
-            <a:off x="8102600" y="4572000"/>
+            <a:off x="8102600" y="3691467"/>
             <a:ext cx="2921000" cy="584775"/>
           </a:xfrm>
           <a:prstGeom prst="rect">
@@ -10526,7 +10711,7 @@
         </p:nvSpPr>
         <p:spPr>
           <a:xfrm>
-            <a:off x="762000" y="6096000"/>
+            <a:off x="762000" y="5520265"/>
             <a:ext cx="10668000" cy="381000"/>
           </a:xfrm>
           <a:prstGeom prst="rect">
@@ -10542,7 +10727,7 @@
           <a:p>
             <a:pPr algn="l"/>
             <a:r>
-              <a:rPr lang="en-US" b="1">
+              <a:rPr lang="en-US" b="1" dirty="0">
                 <a:solidFill>
                   <a:srgbClr val="FF4F1F"/>
                 </a:solidFill>
@@ -11175,7 +11360,7 @@
                   <a:srgbClr val="9CA3AF"/>
                 </a:solidFill>
               </a:rPr>
-              <a:t>/superpowers   ·   MIT license   ·   Free</a:t>
+              <a:t>/superpowers   ·   Free</a:t>
             </a:r>
           </a:p>
         </p:txBody>
@@ -12071,9 +12256,9 @@
           </a:bodyPr>
           <a:lstStyle/>
           <a:p>
-            <a:pPr algn="l"/>
-            <a:r>
-              <a:rPr lang="en-US" sz="1200" b="1">
+            <a:pPr algn="ctr"/>
+            <a:r>
+              <a:rPr lang="en-US" sz="1200" b="1" dirty="0">
                 <a:solidFill>
                   <a:srgbClr val="FAFAFA"/>
                 </a:solidFill>
@@ -15105,100 +15290,6 @@
           </a:p>
         </p:txBody>
       </p:sp>
-      <p:sp>
-        <p:nvSpPr>
-          <p:cNvPr id="19" name="Rectangle 18">
-            <a:extLst>
-              <a:ext uri="{FF2B5EF4-FFF2-40B4-BE49-F238E27FC236}">
-                <a16:creationId xmlns:a16="http://schemas.microsoft.com/office/drawing/2014/main" id="{28FCAED6-2B3C-E04D-BC19-F210C647FE2E}"/>
-              </a:ext>
-            </a:extLst>
-          </p:cNvPr>
-          <p:cNvSpPr/>
-          <p:nvPr/>
-        </p:nvSpPr>
-        <p:spPr>
-          <a:xfrm>
-            <a:off x="762000" y="5588000"/>
-            <a:ext cx="10668000" cy="762000"/>
-          </a:xfrm>
-          <a:prstGeom prst="rect">
-            <a:avLst/>
-          </a:prstGeom>
-          <a:solidFill>
-            <a:srgbClr val="FFF4F0"/>
-          </a:solidFill>
-          <a:ln w="19050" cap="flat" cmpd="sng" algn="ctr">
-            <a:noFill/>
-            <a:prstDash val="solid"/>
-            <a:miter lim="800000"/>
-          </a:ln>
-        </p:spPr>
-        <p:style>
-          <a:lnRef idx="2">
-            <a:schemeClr val="accent1">
-              <a:shade val="15000"/>
-            </a:schemeClr>
-          </a:lnRef>
-          <a:fillRef idx="1">
-            <a:schemeClr val="accent1"/>
-          </a:fillRef>
-          <a:effectRef idx="0">
-            <a:schemeClr val="accent1"/>
-          </a:effectRef>
-          <a:fontRef idx="minor">
-            <a:schemeClr val="lt1"/>
-          </a:fontRef>
-        </p:style>
-        <p:txBody>
-          <a:bodyPr vertOverflow="clip" horzOverflow="clip" rtlCol="0" anchor="t"/>
-          <a:lstStyle/>
-          <a:p>
-            <a:pPr algn="l"/>
-            <a:endParaRPr lang="en-US"/>
-          </a:p>
-        </p:txBody>
-      </p:sp>
-      <p:sp>
-        <p:nvSpPr>
-          <p:cNvPr id="20" name="TextBox 19">
-            <a:extLst>
-              <a:ext uri="{FF2B5EF4-FFF2-40B4-BE49-F238E27FC236}">
-                <a16:creationId xmlns:a16="http://schemas.microsoft.com/office/drawing/2014/main" id="{36F33FB3-35E8-9D43-AEAC-5BBDA3045F30}"/>
-              </a:ext>
-            </a:extLst>
-          </p:cNvPr>
-          <p:cNvSpPr txBox="1"/>
-          <p:nvPr/>
-        </p:nvSpPr>
-        <p:spPr>
-          <a:xfrm>
-            <a:off x="1016000" y="5778500"/>
-            <a:ext cx="10160000" cy="338554"/>
-          </a:xfrm>
-          <a:prstGeom prst="rect">
-            <a:avLst/>
-          </a:prstGeom>
-          <a:noFill/>
-        </p:spPr>
-        <p:txBody>
-          <a:bodyPr vertOverflow="overflow" vert="horz" wrap="square" rtlCol="0" anchor="t">
-            <a:spAutoFit/>
-          </a:bodyPr>
-          <a:lstStyle/>
-          <a:p>
-            <a:pPr algn="l"/>
-            <a:r>
-              <a:rPr lang="en-US" sz="1600" b="1">
-                <a:solidFill>
-                  <a:srgbClr val="FF4F1F"/>
-                </a:solidFill>
-              </a:rPr>
-              <a:t>Graded on the process, not the fix. A good spec with a visible review beats a working fix from “fix it.”</a:t>
-            </a:r>
-          </a:p>
-        </p:txBody>
-      </p:sp>
     </p:spTree>
     <p:extLst>
       <p:ext uri="{BB962C8B-B14F-4D97-AF65-F5344CB8AC3E}">
@@ -15393,12 +15484,12 @@
           <a:p>
             <a:pPr algn="l"/>
             <a:r>
-              <a:rPr lang="en-US" sz="2200">
+              <a:rPr lang="en-US" sz="2200" dirty="0">
                 <a:solidFill>
                   <a:srgbClr val="E5E7EB"/>
                 </a:solidFill>
               </a:rPr>
-              <a:t>Learn the loop — spec, generate, review — and you can switch between Cursor, Claude, Copilot, or any new tool without getting lost.</a:t>
+              <a:t>Learn the loop - spec, generate, review - and you can switch between Cursor, Claude, Copilot, or any new tool without getting lost.</a:t>
             </a:r>
           </a:p>
         </p:txBody>
@@ -19610,9 +19701,9 @@
           </a:bodyPr>
           <a:lstStyle/>
           <a:p>
-            <a:pPr algn="l"/>
-            <a:r>
-              <a:rPr lang="en-US" sz="1200" b="1">
+            <a:pPr algn="ctr"/>
+            <a:r>
+              <a:rPr lang="en-US" sz="1200" b="1" dirty="0">
                 <a:solidFill>
                   <a:srgbClr val="FAFAFA"/>
                 </a:solidFill>
@@ -19838,12 +19929,12 @@
           <a:p>
             <a:pPr algn="l"/>
             <a:r>
-              <a:rPr lang="en-US" sz="2000">
+              <a:rPr lang="en-US" sz="2000" dirty="0">
                 <a:solidFill>
                   <a:srgbClr val="1F2937"/>
                 </a:solidFill>
               </a:rPr>
-              <a:t>How the AI knows about your project. Every tool. One discipline.</a:t>
+              <a:t>How the AI knows about your project.</a:t>
             </a:r>
           </a:p>
         </p:txBody>

</xml_diff>

<commit_message>
Update slides and add course tracker
Co-Authored-By: Claude Sonnet 4.6 <noreply@anthropic.com>
</commit_message>
<xml_diff>
--- a/Agentic Coding.pptx
+++ b/Agentic Coding.pptx
@@ -2,35 +2,35 @@
 <file path=ppt/presentation.xml><?xml version="1.0" encoding="utf-8"?>
 <p:presentation xmlns:a="http://schemas.openxmlformats.org/drawingml/2006/main" xmlns:r="http://schemas.openxmlformats.org/officeDocument/2006/relationships" xmlns:p="http://schemas.openxmlformats.org/presentationml/2006/main" saveSubsetFonts="1" autoCompressPictures="0">
   <p:sldMasterIdLst>
-    <p:sldMasterId id="2147483660" r:id="rId1"/>
+    <p:sldMasterId id="2147483684" r:id="rId1"/>
   </p:sldMasterIdLst>
   <p:notesMasterIdLst>
     <p:notesMasterId r:id="rId25"/>
   </p:notesMasterIdLst>
   <p:sldIdLst>
-    <p:sldId id="295" r:id="rId2"/>
-    <p:sldId id="345" r:id="rId3"/>
-    <p:sldId id="305" r:id="rId4"/>
-    <p:sldId id="346" r:id="rId5"/>
-    <p:sldId id="347" r:id="rId6"/>
-    <p:sldId id="348" r:id="rId7"/>
-    <p:sldId id="331" r:id="rId8"/>
-    <p:sldId id="332" r:id="rId9"/>
-    <p:sldId id="333" r:id="rId10"/>
-    <p:sldId id="349" r:id="rId11"/>
-    <p:sldId id="350" r:id="rId12"/>
-    <p:sldId id="351" r:id="rId13"/>
-    <p:sldId id="352" r:id="rId14"/>
-    <p:sldId id="337" r:id="rId15"/>
-    <p:sldId id="338" r:id="rId16"/>
-    <p:sldId id="353" r:id="rId17"/>
-    <p:sldId id="354" r:id="rId18"/>
-    <p:sldId id="355" r:id="rId19"/>
-    <p:sldId id="356" r:id="rId20"/>
-    <p:sldId id="303" r:id="rId21"/>
-    <p:sldId id="357" r:id="rId22"/>
-    <p:sldId id="343" r:id="rId23"/>
-    <p:sldId id="358" r:id="rId24"/>
+    <p:sldId id="386" r:id="rId2"/>
+    <p:sldId id="361" r:id="rId3"/>
+    <p:sldId id="362" r:id="rId4"/>
+    <p:sldId id="363" r:id="rId5"/>
+    <p:sldId id="364" r:id="rId6"/>
+    <p:sldId id="365" r:id="rId7"/>
+    <p:sldId id="366" r:id="rId8"/>
+    <p:sldId id="367" r:id="rId9"/>
+    <p:sldId id="368" r:id="rId10"/>
+    <p:sldId id="369" r:id="rId11"/>
+    <p:sldId id="370" r:id="rId12"/>
+    <p:sldId id="371" r:id="rId13"/>
+    <p:sldId id="383" r:id="rId14"/>
+    <p:sldId id="372" r:id="rId15"/>
+    <p:sldId id="384" r:id="rId16"/>
+    <p:sldId id="374" r:id="rId17"/>
+    <p:sldId id="375" r:id="rId18"/>
+    <p:sldId id="376" r:id="rId19"/>
+    <p:sldId id="377" r:id="rId20"/>
+    <p:sldId id="378" r:id="rId21"/>
+    <p:sldId id="385" r:id="rId22"/>
+    <p:sldId id="380" r:id="rId23"/>
+    <p:sldId id="381" r:id="rId24"/>
   </p:sldIdLst>
   <p:sldSz cx="12192000" cy="6858000"/>
   <p:notesSz cx="6858000" cy="9144000"/>
@@ -4550,7 +4550,7 @@
             <a:avLst/>
           </a:prstGeom>
           <a:solidFill>
-            <a:srgbClr val="FF4F1F"/>
+            <a:srgbClr val="1F6FEB"/>
           </a:solidFill>
           <a:ln>
             <a:noFill/>
@@ -4573,17 +4573,17 @@
   </p:cSld>
   <p:clrMap bg1="lt1" tx1="dk1" bg2="lt2" tx2="dk2" accent1="accent1" accent2="accent2" accent3="accent3" accent4="accent4" accent5="accent5" accent6="accent6" hlink="hlink" folHlink="folHlink"/>
   <p:sldLayoutIdLst>
-    <p:sldLayoutId id="2147483661" r:id="rId1"/>
-    <p:sldLayoutId id="2147483662" r:id="rId2"/>
-    <p:sldLayoutId id="2147483663" r:id="rId3"/>
-    <p:sldLayoutId id="2147483664" r:id="rId4"/>
-    <p:sldLayoutId id="2147483665" r:id="rId5"/>
-    <p:sldLayoutId id="2147483666" r:id="rId6"/>
-    <p:sldLayoutId id="2147483667" r:id="rId7"/>
-    <p:sldLayoutId id="2147483668" r:id="rId8"/>
-    <p:sldLayoutId id="2147483669" r:id="rId9"/>
-    <p:sldLayoutId id="2147483670" r:id="rId10"/>
-    <p:sldLayoutId id="2147483671" r:id="rId11"/>
+    <p:sldLayoutId id="2147483685" r:id="rId1"/>
+    <p:sldLayoutId id="2147483686" r:id="rId2"/>
+    <p:sldLayoutId id="2147483687" r:id="rId3"/>
+    <p:sldLayoutId id="2147483688" r:id="rId4"/>
+    <p:sldLayoutId id="2147483689" r:id="rId5"/>
+    <p:sldLayoutId id="2147483690" r:id="rId6"/>
+    <p:sldLayoutId id="2147483691" r:id="rId7"/>
+    <p:sldLayoutId id="2147483692" r:id="rId8"/>
+    <p:sldLayoutId id="2147483693" r:id="rId9"/>
+    <p:sldLayoutId id="2147483694" r:id="rId10"/>
+    <p:sldLayoutId id="2147483695" r:id="rId11"/>
   </p:sldLayoutIdLst>
   <p:txStyles>
     <p:titleStyle>
@@ -4906,7 +4906,7 @@
             <a:avLst/>
           </a:prstGeom>
           <a:solidFill>
-            <a:srgbClr val="FF4F1F"/>
+            <a:srgbClr val="1F6FEB"/>
           </a:solidFill>
           <a:ln w="19050" cap="flat" cmpd="sng" algn="ctr">
             <a:noFill/>
@@ -4941,46 +4941,6 @@
       </p:sp>
       <p:sp>
         <p:nvSpPr>
-          <p:cNvPr id="5" name="TextBox 4">
-            <a:extLst>
-              <a:ext uri="{FF2B5EF4-FFF2-40B4-BE49-F238E27FC236}">
-                <a16:creationId xmlns:a16="http://schemas.microsoft.com/office/drawing/2014/main" id="{BA72F5B0-0FD1-0641-81F0-AF535FD9657A}"/>
-              </a:ext>
-            </a:extLst>
-          </p:cNvPr>
-          <p:cNvSpPr txBox="1"/>
-          <p:nvPr/>
-        </p:nvSpPr>
-        <p:spPr>
-          <a:xfrm>
-            <a:off x="762000" y="1397000"/>
-            <a:ext cx="8890000" cy="307777"/>
-          </a:xfrm>
-          <a:prstGeom prst="rect">
-            <a:avLst/>
-          </a:prstGeom>
-          <a:noFill/>
-        </p:spPr>
-        <p:txBody>
-          <a:bodyPr vertOverflow="overflow" vert="horz" wrap="square" rtlCol="0" anchor="t">
-            <a:spAutoFit/>
-          </a:bodyPr>
-          <a:lstStyle/>
-          <a:p>
-            <a:pPr algn="l"/>
-            <a:r>
-              <a:rPr lang="en-US" sz="1400" b="1">
-                <a:solidFill>
-                  <a:srgbClr val="FF4F1F"/>
-                </a:solidFill>
-              </a:rPr>
-              <a:t>WORKSHOP · 60 MIN</a:t>
-            </a:r>
-          </a:p>
-        </p:txBody>
-      </p:sp>
-      <p:sp>
-        <p:nvSpPr>
           <p:cNvPr id="6" name="TextBox 5">
             <a:extLst>
               <a:ext uri="{FF2B5EF4-FFF2-40B4-BE49-F238E27FC236}">
@@ -5071,7 +5031,7 @@
     </p:spTree>
     <p:extLst>
       <p:ext uri="{BB962C8B-B14F-4D97-AF65-F5344CB8AC3E}">
-        <p14:creationId xmlns:p14="http://schemas.microsoft.com/office/powerpoint/2010/main" val="4150382855"/>
+        <p14:creationId xmlns:p14="http://schemas.microsoft.com/office/powerpoint/2010/main" val="1581615083"/>
       </p:ext>
     </p:extLst>
   </p:cSld>
@@ -5130,7 +5090,7 @@
             <a:r>
               <a:rPr lang="en-US" sz="1400" b="1">
                 <a:solidFill>
-                  <a:srgbClr val="FF4F1F"/>
+                  <a:srgbClr val="1F6FEB"/>
                 </a:solidFill>
               </a:rPr>
               <a:t>THE PROBLEM</a:t>
@@ -5609,7 +5569,7 @@
             <a:avLst/>
           </a:prstGeom>
           <a:solidFill>
-            <a:srgbClr val="FF4F1F"/>
+            <a:srgbClr val="1F6FEB"/>
           </a:solidFill>
           <a:ln w="19050" cap="flat" cmpd="sng" algn="ctr">
             <a:noFill/>
@@ -5674,7 +5634,7 @@
             <a:r>
               <a:rPr lang="en-US" sz="1400" b="1">
                 <a:solidFill>
-                  <a:srgbClr val="FF4F1F"/>
+                  <a:srgbClr val="1F6FEB"/>
                 </a:solidFill>
               </a:rPr>
               <a:t>WITH a context file</a:t>
@@ -5885,7 +5845,7 @@
     </p:spTree>
     <p:extLst>
       <p:ext uri="{BB962C8B-B14F-4D97-AF65-F5344CB8AC3E}">
-        <p14:creationId xmlns:p14="http://schemas.microsoft.com/office/powerpoint/2010/main" val="2243467248"/>
+        <p14:creationId xmlns:p14="http://schemas.microsoft.com/office/powerpoint/2010/main" val="2137552836"/>
       </p:ext>
     </p:extLst>
   </p:cSld>
@@ -5944,7 +5904,7 @@
             <a:r>
               <a:rPr lang="en-US" sz="1400" b="1">
                 <a:solidFill>
-                  <a:srgbClr val="FF4F1F"/>
+                  <a:srgbClr val="1F6FEB"/>
                 </a:solidFill>
               </a:rPr>
               <a:t>CONTEXT FILES BY TOOL</a:t>
@@ -6000,13 +5960,7 @@
           <p:cNvGraphicFramePr>
             <a:graphicFrameLocks noGrp="1"/>
           </p:cNvGraphicFramePr>
-          <p:nvPr>
-            <p:extLst>
-              <p:ext uri="{D42A27DB-BD31-4B8C-83A1-F6EECF244321}">
-                <p14:modId xmlns:p14="http://schemas.microsoft.com/office/powerpoint/2010/main" val="1691475843"/>
-              </p:ext>
-            </p:extLst>
-          </p:nvPr>
+          <p:nvPr/>
         </p:nvGraphicFramePr>
         <p:xfrm>
           <a:off x="762000" y="1651000"/>
@@ -6049,7 +6003,7 @@
                     <a:p>
                       <a:pPr algn="l"/>
                       <a:r>
-                        <a:rPr lang="en-US" sz="1600" b="1">
+                        <a:rPr lang="en-US" sz="1600" b="1" dirty="0">
                           <a:solidFill>
                             <a:srgbClr val="FAFAFA"/>
                           </a:solidFill>
@@ -6432,7 +6386,7 @@
                   </a:txBody>
                   <a:tcPr anchor="ctr">
                     <a:solidFill>
-                      <a:srgbClr val="FF4F1F"/>
+                      <a:srgbClr val="1F6FEB"/>
                     </a:solidFill>
                   </a:tcPr>
                 </a:tc>
@@ -6453,7 +6407,7 @@
                   </a:txBody>
                   <a:tcPr anchor="ctr">
                     <a:solidFill>
-                      <a:srgbClr val="FF4F1F"/>
+                      <a:srgbClr val="1F6FEB"/>
                     </a:solidFill>
                   </a:tcPr>
                 </a:tc>
@@ -6474,7 +6428,7 @@
                   </a:txBody>
                   <a:tcPr anchor="ctr">
                     <a:solidFill>
-                      <a:srgbClr val="FF4F1F"/>
+                      <a:srgbClr val="1F6FEB"/>
                     </a:solidFill>
                   </a:tcPr>
                 </a:tc>
@@ -6571,7 +6525,7 @@
     </p:spTree>
     <p:extLst>
       <p:ext uri="{BB962C8B-B14F-4D97-AF65-F5344CB8AC3E}">
-        <p14:creationId xmlns:p14="http://schemas.microsoft.com/office/powerpoint/2010/main" val="2863840288"/>
+        <p14:creationId xmlns:p14="http://schemas.microsoft.com/office/powerpoint/2010/main" val="1259385321"/>
       </p:ext>
     </p:extLst>
   </p:cSld>
@@ -6630,7 +6584,7 @@
             <a:r>
               <a:rPr lang="en-US" sz="1400" b="1">
                 <a:solidFill>
-                  <a:srgbClr val="FF4F1F"/>
+                  <a:srgbClr val="1F6FEB"/>
                 </a:solidFill>
               </a:rPr>
               <a:t>INSIDE A CLAUDE.MD / AGENTS.MD</a:t>
@@ -6695,7 +6649,7 @@
             <a:avLst/>
           </a:prstGeom>
           <a:solidFill>
-            <a:srgbClr val="FF4F1F"/>
+            <a:srgbClr val="1F6FEB"/>
           </a:solidFill>
           <a:ln w="19050" cap="flat" cmpd="sng" algn="ctr">
             <a:noFill/>
@@ -6825,7 +6779,7 @@
             <a:avLst/>
           </a:prstGeom>
           <a:solidFill>
-            <a:srgbClr val="FF4F1F"/>
+            <a:srgbClr val="1F6FEB"/>
           </a:solidFill>
           <a:ln w="19050" cap="flat" cmpd="sng" algn="ctr">
             <a:noFill/>
@@ -6955,7 +6909,7 @@
             <a:avLst/>
           </a:prstGeom>
           <a:solidFill>
-            <a:srgbClr val="FF4F1F"/>
+            <a:srgbClr val="1F6FEB"/>
           </a:solidFill>
           <a:ln w="19050" cap="flat" cmpd="sng" algn="ctr">
             <a:noFill/>
@@ -7085,7 +7039,7 @@
             <a:avLst/>
           </a:prstGeom>
           <a:solidFill>
-            <a:srgbClr val="FF4F1F"/>
+            <a:srgbClr val="1F6FEB"/>
           </a:solidFill>
           <a:ln w="19050" cap="flat" cmpd="sng" algn="ctr">
             <a:noFill/>
@@ -7215,7 +7169,7 @@
             <a:avLst/>
           </a:prstGeom>
           <a:solidFill>
-            <a:srgbClr val="FF4F1F"/>
+            <a:srgbClr val="1F6FEB"/>
           </a:solidFill>
           <a:ln w="19050" cap="flat" cmpd="sng" algn="ctr">
             <a:noFill/>
@@ -7410,7 +7364,7 @@
             <a:r>
               <a:rPr lang="en-US" sz="1300" b="1">
                 <a:solidFill>
-                  <a:srgbClr val="FF4F1F"/>
+                  <a:srgbClr val="1F6FEB"/>
                 </a:solidFill>
               </a:rPr>
               <a:t>RULE OF THUMB</a:t>
@@ -7604,7 +7558,7 @@
     </p:spTree>
     <p:extLst>
       <p:ext uri="{BB962C8B-B14F-4D97-AF65-F5344CB8AC3E}">
-        <p14:creationId xmlns:p14="http://schemas.microsoft.com/office/powerpoint/2010/main" val="2551923562"/>
+        <p14:creationId xmlns:p14="http://schemas.microsoft.com/office/powerpoint/2010/main" val="3385641028"/>
       </p:ext>
     </p:extLst>
   </p:cSld>
@@ -7663,7 +7617,7 @@
             <a:r>
               <a:rPr lang="en-US" sz="1400" b="1">
                 <a:solidFill>
-                  <a:srgbClr val="FF4F1F"/>
+                  <a:srgbClr val="1F6FEB"/>
                 </a:solidFill>
               </a:rPr>
               <a:t>USING MULTIPLE AI TOOLS?</a:t>
@@ -7799,7 +7753,7 @@
             <a:r>
               <a:rPr lang="en-US" sz="1300" b="1">
                 <a:solidFill>
-                  <a:srgbClr val="FF4F1F"/>
+                  <a:srgbClr val="1F6FEB"/>
                 </a:solidFill>
               </a:rPr>
               <a:t>OPTION 1</a:t>
@@ -8125,7 +8079,7 @@
             <a:r>
               <a:rPr lang="en-US" sz="1300" b="1">
                 <a:solidFill>
-                  <a:srgbClr val="FF4F1F"/>
+                  <a:srgbClr val="1F6FEB"/>
                 </a:solidFill>
               </a:rPr>
               <a:t>OPTION 2</a:t>
@@ -8393,11 +8347,11 @@
             <a:avLst/>
           </a:prstGeom>
           <a:solidFill>
-            <a:srgbClr val="FFF4ED"/>
+            <a:srgbClr val="EEF4FE"/>
           </a:solidFill>
           <a:ln w="12700" cap="flat" cmpd="sng" algn="ctr">
             <a:solidFill>
-              <a:srgbClr val="FF4F1F"/>
+              <a:srgbClr val="1F6FEB"/>
             </a:solidFill>
             <a:prstDash val="solid"/>
             <a:miter lim="800000"/>
@@ -8543,7 +8497,7 @@
     </p:spTree>
     <p:extLst>
       <p:ext uri="{BB962C8B-B14F-4D97-AF65-F5344CB8AC3E}">
-        <p14:creationId xmlns:p14="http://schemas.microsoft.com/office/powerpoint/2010/main" val="3246581148"/>
+        <p14:creationId xmlns:p14="http://schemas.microsoft.com/office/powerpoint/2010/main" val="3845001605"/>
       </p:ext>
     </p:extLst>
   </p:cSld>
@@ -8602,7 +8556,7 @@
             <a:r>
               <a:rPr lang="en-US" sz="20000" b="1">
                 <a:solidFill>
-                  <a:srgbClr val="FF4F1F"/>
+                  <a:srgbClr val="1F6FEB"/>
                 </a:solidFill>
               </a:rPr>
               <a:t>04</a:t>
@@ -8642,7 +8596,7 @@
             <a:r>
               <a:rPr lang="en-US" sz="1600" b="1">
                 <a:solidFill>
-                  <a:srgbClr val="FF4F1F"/>
+                  <a:srgbClr val="1F6FEB"/>
                 </a:solidFill>
               </a:rPr>
               <a:t>PART 04  ·  17 MIN</a:t>
@@ -8729,7 +8683,7 @@
     </p:spTree>
     <p:extLst>
       <p:ext uri="{BB962C8B-B14F-4D97-AF65-F5344CB8AC3E}">
-        <p14:creationId xmlns:p14="http://schemas.microsoft.com/office/powerpoint/2010/main" val="2247716666"/>
+        <p14:creationId xmlns:p14="http://schemas.microsoft.com/office/powerpoint/2010/main" val="452151304"/>
       </p:ext>
     </p:extLst>
   </p:cSld>
@@ -8788,7 +8742,7 @@
             <a:r>
               <a:rPr lang="en-US" sz="1400" b="1">
                 <a:solidFill>
-                  <a:srgbClr val="FF4F1F"/>
+                  <a:srgbClr val="1F6FEB"/>
                 </a:solidFill>
               </a:rPr>
               <a:t>THE SPEC → GENERATE → REVIEW LOOP</a:t>
@@ -8920,7 +8874,7 @@
             <a:r>
               <a:rPr lang="en-US" sz="2200" b="1">
                 <a:solidFill>
-                  <a:srgbClr val="FF4F1F"/>
+                  <a:srgbClr val="1F6FEB"/>
                 </a:solidFill>
               </a:rPr>
               <a:t>1</a:t>
@@ -9123,7 +9077,7 @@
             <a:avLst/>
           </a:prstGeom>
           <a:solidFill>
-            <a:srgbClr val="FF4F1F"/>
+            <a:srgbClr val="1F6FEB"/>
           </a:solidFill>
           <a:ln w="19050" cap="flat" cmpd="sng" algn="ctr">
             <a:noFill/>
@@ -9268,7 +9222,7 @@
             <a:r>
               <a:rPr lang="en-US" sz="1600" i="1">
                 <a:solidFill>
-                  <a:srgbClr val="FFE4D9"/>
+                  <a:srgbClr val="D9E5FB"/>
                 </a:solidFill>
               </a:rPr>
               <a:t>(AI writes)</a:t>
@@ -9458,7 +9412,7 @@
             <a:r>
               <a:rPr lang="en-US" sz="2200" b="1">
                 <a:solidFill>
-                  <a:srgbClr val="FF4F1F"/>
+                  <a:srgbClr val="1F6FEB"/>
                 </a:solidFill>
               </a:rPr>
               <a:t>3</a:t>
@@ -9618,7 +9572,7 @@
             <a:r>
               <a:rPr lang="en-US" sz="2000" b="1">
                 <a:solidFill>
-                  <a:srgbClr val="FF4F1F"/>
+                  <a:srgbClr val="1F6FEB"/>
                 </a:solidFill>
               </a:rPr>
               <a:t>↺  When the output is wrong, fix the SPEC and regenerate. Don't patch the code.</a:t>
@@ -9669,7 +9623,7 @@
     </p:spTree>
     <p:extLst>
       <p:ext uri="{BB962C8B-B14F-4D97-AF65-F5344CB8AC3E}">
-        <p14:creationId xmlns:p14="http://schemas.microsoft.com/office/powerpoint/2010/main" val="32545152"/>
+        <p14:creationId xmlns:p14="http://schemas.microsoft.com/office/powerpoint/2010/main" val="4177969448"/>
       </p:ext>
     </p:extLst>
   </p:cSld>
@@ -9728,7 +9682,7 @@
             <a:r>
               <a:rPr lang="en-US" sz="1400" b="1">
                 <a:solidFill>
-                  <a:srgbClr val="FF4F1F"/>
+                  <a:srgbClr val="1F6FEB"/>
                 </a:solidFill>
               </a:rPr>
               <a:t>ANATOMY OF A SPEC</a:t>
@@ -9900,7 +9854,7 @@
             <a:avLst/>
           </a:prstGeom>
           <a:solidFill>
-            <a:srgbClr val="FF4F1F"/>
+            <a:srgbClr val="1F6FEB"/>
           </a:solidFill>
           <a:ln w="19050" cap="flat" cmpd="sng" algn="ctr">
             <a:noFill/>
@@ -10030,7 +9984,7 @@
             <a:avLst/>
           </a:prstGeom>
           <a:solidFill>
-            <a:srgbClr val="FF4F1F"/>
+            <a:srgbClr val="1F6FEB"/>
           </a:solidFill>
           <a:ln w="19050" cap="flat" cmpd="sng" algn="ctr">
             <a:noFill/>
@@ -10160,7 +10114,7 @@
             <a:avLst/>
           </a:prstGeom>
           <a:solidFill>
-            <a:srgbClr val="FF4F1F"/>
+            <a:srgbClr val="1F6FEB"/>
           </a:solidFill>
           <a:ln w="19050" cap="flat" cmpd="sng" algn="ctr">
             <a:noFill/>
@@ -10312,7 +10266,7 @@
     </p:spTree>
     <p:extLst>
       <p:ext uri="{BB962C8B-B14F-4D97-AF65-F5344CB8AC3E}">
-        <p14:creationId xmlns:p14="http://schemas.microsoft.com/office/powerpoint/2010/main" val="653824666"/>
+        <p14:creationId xmlns:p14="http://schemas.microsoft.com/office/powerpoint/2010/main" val="2213714120"/>
       </p:ext>
     </p:extLst>
   </p:cSld>
@@ -10371,7 +10325,7 @@
             <a:r>
               <a:rPr lang="en-US" sz="1400" b="1">
                 <a:solidFill>
-                  <a:srgbClr val="FF4F1F"/>
+                  <a:srgbClr val="1F6FEB"/>
                 </a:solidFill>
               </a:rPr>
               <a:t>WHY REVIEW IS NON-NEGOTIABLE</a:t>
@@ -10440,7 +10394,7 @@
           </a:solidFill>
           <a:ln w="25400" cap="flat" cmpd="sng" algn="ctr">
             <a:solidFill>
-              <a:srgbClr val="FF4F1F"/>
+              <a:srgbClr val="1F6FEB"/>
             </a:solidFill>
             <a:prstDash val="solid"/>
             <a:miter lim="800000"/>
@@ -10572,7 +10526,7 @@
           </a:solidFill>
           <a:ln w="25400" cap="flat" cmpd="sng" algn="ctr">
             <a:solidFill>
-              <a:srgbClr val="FF4F1F"/>
+              <a:srgbClr val="1F6FEB"/>
             </a:solidFill>
             <a:prstDash val="solid"/>
             <a:miter lim="800000"/>
@@ -10704,7 +10658,7 @@
           </a:solidFill>
           <a:ln w="25400" cap="flat" cmpd="sng" algn="ctr">
             <a:solidFill>
-              <a:srgbClr val="FF4F1F"/>
+              <a:srgbClr val="1F6FEB"/>
             </a:solidFill>
             <a:prstDash val="solid"/>
             <a:miter lim="800000"/>
@@ -10843,7 +10797,7 @@
             <a:r>
               <a:rPr lang="en-US" b="1" dirty="0">
                 <a:solidFill>
-                  <a:srgbClr val="FF4F1F"/>
+                  <a:srgbClr val="1F6FEB"/>
                 </a:solidFill>
               </a:rPr>
               <a:t>A 30-second diff review catches 90% of the problems.</a:t>
@@ -10894,7 +10848,7 @@
     </p:spTree>
     <p:extLst>
       <p:ext uri="{BB962C8B-B14F-4D97-AF65-F5344CB8AC3E}">
-        <p14:creationId xmlns:p14="http://schemas.microsoft.com/office/powerpoint/2010/main" val="2949890496"/>
+        <p14:creationId xmlns:p14="http://schemas.microsoft.com/office/powerpoint/2010/main" val="1459072136"/>
       </p:ext>
     </p:extLst>
   </p:cSld>
@@ -11007,7 +10961,7 @@
             <a:r>
               <a:rPr lang="en-US" sz="1400" b="1">
                 <a:solidFill>
-                  <a:srgbClr val="FF4F1F"/>
+                  <a:srgbClr val="1F6FEB"/>
                 </a:solidFill>
               </a:rPr>
               <a:t>THE PRODUCTION VERSION</a:t>
@@ -11127,7 +11081,7 @@
             <a:r>
               <a:rPr lang="en-US" sz="4400" b="1">
                 <a:solidFill>
-                  <a:srgbClr val="FF4F1F"/>
+                  <a:srgbClr val="1F6FEB"/>
                 </a:solidFill>
               </a:rPr>
               <a:t>~175k</a:t>
@@ -11207,7 +11161,7 @@
             <a:r>
               <a:rPr lang="en-US" sz="4400" b="1">
                 <a:solidFill>
-                  <a:srgbClr val="FF4F1F"/>
+                  <a:srgbClr val="1F6FEB"/>
                 </a:solidFill>
               </a:rPr>
               <a:t>14</a:t>
@@ -11287,7 +11241,7 @@
             <a:r>
               <a:rPr lang="en-US" sz="4400" b="1">
                 <a:solidFill>
-                  <a:srgbClr val="FF4F1F"/>
+                  <a:srgbClr val="1F6FEB"/>
                 </a:solidFill>
               </a:rPr>
               <a:t>Jan '26</a:t>
@@ -11367,7 +11321,7 @@
             <a:r>
               <a:rPr lang="en-US" sz="4400" b="1">
                 <a:solidFill>
-                  <a:srgbClr val="FF4F1F"/>
+                  <a:srgbClr val="1F6FEB"/>
                 </a:solidFill>
               </a:rPr>
               <a:t>8+</a:t>
@@ -11522,7 +11476,7 @@
     </p:spTree>
     <p:extLst>
       <p:ext uri="{BB962C8B-B14F-4D97-AF65-F5344CB8AC3E}">
-        <p14:creationId xmlns:p14="http://schemas.microsoft.com/office/powerpoint/2010/main" val="2487053489"/>
+        <p14:creationId xmlns:p14="http://schemas.microsoft.com/office/powerpoint/2010/main" val="3958395508"/>
       </p:ext>
     </p:extLst>
   </p:cSld>
@@ -11581,7 +11535,7 @@
             <a:r>
               <a:rPr lang="en-US" sz="1400" b="1">
                 <a:solidFill>
-                  <a:srgbClr val="FF4F1F"/>
+                  <a:srgbClr val="1F6FEB"/>
                 </a:solidFill>
               </a:rPr>
               <a:t>HOW SUPERPOWERS WORKS</a:t>
@@ -11768,7 +11722,7 @@
                       <a:r>
                         <a:rPr lang="en-US" sz="1200" dirty="0">
                           <a:solidFill>
-                            <a:srgbClr val="FF4F1F"/>
+                            <a:srgbClr val="1F6FEB"/>
                           </a:solidFill>
                           <a:latin typeface="Consolas"/>
                           <a:cs typeface="Consolas"/>
@@ -11828,7 +11782,7 @@
                       <a:r>
                         <a:rPr lang="en-US" sz="1200">
                           <a:solidFill>
-                            <a:srgbClr val="FF4F1F"/>
+                            <a:srgbClr val="1F6FEB"/>
                           </a:solidFill>
                           <a:latin typeface="Consolas"/>
                           <a:cs typeface="Consolas"/>
@@ -11888,7 +11842,7 @@
                       <a:r>
                         <a:rPr lang="en-US" sz="1200">
                           <a:solidFill>
-                            <a:srgbClr val="FF4F1F"/>
+                            <a:srgbClr val="1F6FEB"/>
                           </a:solidFill>
                           <a:latin typeface="Consolas"/>
                           <a:cs typeface="Consolas"/>
@@ -11948,7 +11902,7 @@
                       <a:r>
                         <a:rPr lang="en-US" sz="1200">
                           <a:solidFill>
-                            <a:srgbClr val="FF4F1F"/>
+                            <a:srgbClr val="1F6FEB"/>
                           </a:solidFill>
                           <a:latin typeface="Consolas"/>
                           <a:cs typeface="Consolas"/>
@@ -12008,7 +11962,7 @@
                       <a:r>
                         <a:rPr lang="en-US" sz="1200">
                           <a:solidFill>
-                            <a:srgbClr val="FF4F1F"/>
+                            <a:srgbClr val="1F6FEB"/>
                           </a:solidFill>
                           <a:latin typeface="Consolas"/>
                           <a:cs typeface="Consolas"/>
@@ -12068,7 +12022,7 @@
                       <a:r>
                         <a:rPr lang="en-US" sz="1200">
                           <a:solidFill>
-                            <a:srgbClr val="FF4F1F"/>
+                            <a:srgbClr val="1F6FEB"/>
                           </a:solidFill>
                           <a:latin typeface="Consolas"/>
                           <a:cs typeface="Consolas"/>
@@ -12174,7 +12128,7 @@
                       <a:r>
                         <a:rPr lang="en-US" sz="1200">
                           <a:solidFill>
-                            <a:srgbClr val="FF4F1F"/>
+                            <a:srgbClr val="1F6FEB"/>
                           </a:solidFill>
                           <a:latin typeface="Consolas"/>
                           <a:cs typeface="Consolas"/>
@@ -12425,7 +12379,7 @@
     </p:spTree>
     <p:extLst>
       <p:ext uri="{BB962C8B-B14F-4D97-AF65-F5344CB8AC3E}">
-        <p14:creationId xmlns:p14="http://schemas.microsoft.com/office/powerpoint/2010/main" val="159846302"/>
+        <p14:creationId xmlns:p14="http://schemas.microsoft.com/office/powerpoint/2010/main" val="769454134"/>
       </p:ext>
     </p:extLst>
   </p:cSld>
@@ -12484,7 +12438,7 @@
             <a:r>
               <a:rPr lang="en-US" sz="1400" b="1">
                 <a:solidFill>
-                  <a:srgbClr val="FF4F1F"/>
+                  <a:srgbClr val="1F6FEB"/>
                 </a:solidFill>
               </a:rPr>
               <a:t>WHAT YOU'LL WALK AWAY WITH</a:t>
@@ -12616,7 +12570,7 @@
             <a:r>
               <a:rPr lang="en-US" sz="1400" b="1">
                 <a:solidFill>
-                  <a:srgbClr val="FF4F1F"/>
+                  <a:srgbClr val="1F6FEB"/>
                 </a:solidFill>
               </a:rPr>
               <a:t>01</a:t>
@@ -12792,7 +12746,7 @@
             <a:r>
               <a:rPr lang="en-US" sz="1400" b="1">
                 <a:solidFill>
-                  <a:srgbClr val="FF4F1F"/>
+                  <a:srgbClr val="1F6FEB"/>
                 </a:solidFill>
               </a:rPr>
               <a:t>02</a:t>
@@ -12967,7 +12921,7 @@
             <a:r>
               <a:rPr lang="en-US" sz="1400" b="1">
                 <a:solidFill>
-                  <a:srgbClr val="FF4F1F"/>
+                  <a:srgbClr val="1F6FEB"/>
                 </a:solidFill>
               </a:rPr>
               <a:t>03</a:t>
@@ -13143,7 +13097,7 @@
             <a:r>
               <a:rPr lang="en-US" sz="1400" b="1">
                 <a:solidFill>
-                  <a:srgbClr val="FF4F1F"/>
+                  <a:srgbClr val="1F6FEB"/>
                 </a:solidFill>
               </a:rPr>
               <a:t>04</a:t>
@@ -13274,7 +13228,7 @@
     </p:spTree>
     <p:extLst>
       <p:ext uri="{BB962C8B-B14F-4D97-AF65-F5344CB8AC3E}">
-        <p14:creationId xmlns:p14="http://schemas.microsoft.com/office/powerpoint/2010/main" val="754964237"/>
+        <p14:creationId xmlns:p14="http://schemas.microsoft.com/office/powerpoint/2010/main" val="4023055548"/>
       </p:ext>
     </p:extLst>
   </p:cSld>
@@ -13333,7 +13287,7 @@
             <a:r>
               <a:rPr lang="en-US" sz="1400" b="1">
                 <a:solidFill>
-                  <a:srgbClr val="FF4F1F"/>
+                  <a:srgbClr val="1F6FEB"/>
                 </a:solidFill>
               </a:rPr>
               <a:t>SUPERPOWERS  ·  INSTALL</a:t>
@@ -13413,7 +13367,7 @@
             <a:r>
               <a:rPr lang="en-US" sz="1300" b="1">
                 <a:solidFill>
-                  <a:srgbClr val="FF4F1F"/>
+                  <a:srgbClr val="1F6FEB"/>
                 </a:solidFill>
               </a:rPr>
               <a:t>OFFICIAL MARKETPLACE  ·  RECOMMENDED</a:t>
@@ -13498,22 +13452,39 @@
           <a:noFill/>
         </p:spPr>
         <p:txBody>
-          <a:bodyPr vertOverflow="overflow" vert="horz" wrap="square" rtlCol="0" anchor="t">
+          <a:bodyPr vertOverflow="overflow" vert="horz" wrap="square" rtlCol="0" anchor="ctr">
             <a:noAutofit/>
           </a:bodyPr>
           <a:lstStyle/>
           <a:p>
             <a:pPr algn="l"/>
             <a:r>
-              <a:rPr lang="en-US">
+              <a:rPr lang="en-US" dirty="0">
                 <a:solidFill>
                   <a:srgbClr val="FAFAFA"/>
                 </a:solidFill>
                 <a:latin typeface="Consolas"/>
                 <a:cs typeface="Consolas"/>
               </a:rPr>
-              <a:t>/plugin install superpowers@claude-plugins-official</a:t>
-            </a:r>
+              <a:t>/plugin install </a:t>
+            </a:r>
+            <a:r>
+              <a:rPr lang="en-US" dirty="0" err="1">
+                <a:solidFill>
+                  <a:srgbClr val="FAFAFA"/>
+                </a:solidFill>
+                <a:latin typeface="Consolas"/>
+                <a:cs typeface="Consolas"/>
+              </a:rPr>
+              <a:t>superpowers@claude-plugins-official</a:t>
+            </a:r>
+            <a:endParaRPr lang="en-US" dirty="0">
+              <a:solidFill>
+                <a:srgbClr val="FAFAFA"/>
+              </a:solidFill>
+              <a:latin typeface="Consolas"/>
+              <a:cs typeface="Consolas"/>
+            </a:endParaRPr>
           </a:p>
         </p:txBody>
       </p:sp>
@@ -13589,7 +13560,7 @@
             <a:r>
               <a:rPr lang="en-US" sz="1300" b="1">
                 <a:solidFill>
-                  <a:srgbClr val="FF4F1F"/>
+                  <a:srgbClr val="1F6FEB"/>
                 </a:solidFill>
               </a:rPr>
               <a:t>LATEST FEATURES</a:t>
@@ -13674,23 +13645,60 @@
           <a:noFill/>
         </p:spPr>
         <p:txBody>
-          <a:bodyPr vertOverflow="overflow" vert="horz" wrap="square" rtlCol="0" anchor="t">
+          <a:bodyPr vertOverflow="overflow" vert="horz" wrap="square" rtlCol="0" anchor="ctr">
             <a:noAutofit/>
           </a:bodyPr>
           <a:lstStyle/>
           <a:p>
             <a:pPr algn="l"/>
             <a:r>
-              <a:rPr lang="en-US">
+              <a:rPr lang="en-US" dirty="0">
                 <a:solidFill>
                   <a:srgbClr val="FAFAFA"/>
                 </a:solidFill>
                 <a:latin typeface="Consolas"/>
                 <a:cs typeface="Consolas"/>
               </a:rPr>
-              <a:t>/plugin marketplace add obra/superpowers-marketplace
-/plugin install superpowers@superpowers-marketplace</a:t>
-            </a:r>
+              <a:t>/plugin marketplace add </a:t>
+            </a:r>
+            <a:r>
+              <a:rPr lang="en-US" dirty="0" err="1">
+                <a:solidFill>
+                  <a:srgbClr val="FAFAFA"/>
+                </a:solidFill>
+                <a:latin typeface="Consolas"/>
+                <a:cs typeface="Consolas"/>
+              </a:rPr>
+              <a:t>obra</a:t>
+            </a:r>
+            <a:r>
+              <a:rPr lang="en-US" dirty="0">
+                <a:solidFill>
+                  <a:srgbClr val="FAFAFA"/>
+                </a:solidFill>
+                <a:latin typeface="Consolas"/>
+                <a:cs typeface="Consolas"/>
+              </a:rPr>
+              <a:t>/superpowers-marketplace
+/plugin install </a:t>
+            </a:r>
+            <a:r>
+              <a:rPr lang="en-US" dirty="0" err="1">
+                <a:solidFill>
+                  <a:srgbClr val="FAFAFA"/>
+                </a:solidFill>
+                <a:latin typeface="Consolas"/>
+                <a:cs typeface="Consolas"/>
+              </a:rPr>
+              <a:t>superpowers@superpowers-marketplace</a:t>
+            </a:r>
+            <a:endParaRPr lang="en-US" dirty="0">
+              <a:solidFill>
+                <a:srgbClr val="FAFAFA"/>
+              </a:solidFill>
+              <a:latin typeface="Consolas"/>
+              <a:cs typeface="Consolas"/>
+            </a:endParaRPr>
           </a:p>
         </p:txBody>
       </p:sp>
@@ -13817,7 +13825,7 @@
     </p:spTree>
     <p:extLst>
       <p:ext uri="{BB962C8B-B14F-4D97-AF65-F5344CB8AC3E}">
-        <p14:creationId xmlns:p14="http://schemas.microsoft.com/office/powerpoint/2010/main" val="2707146492"/>
+        <p14:creationId xmlns:p14="http://schemas.microsoft.com/office/powerpoint/2010/main" val="482871391"/>
       </p:ext>
     </p:extLst>
   </p:cSld>
@@ -13876,7 +13884,7 @@
             <a:r>
               <a:rPr lang="en-US" sz="1400" b="1">
                 <a:solidFill>
-                  <a:srgbClr val="FF4F1F"/>
+                  <a:srgbClr val="1F6FEB"/>
                 </a:solidFill>
               </a:rPr>
               <a:t>HONEST CAVEAT</a:t>
@@ -14001,7 +14009,7 @@
             <a:avLst/>
           </a:prstGeom>
           <a:solidFill>
-            <a:srgbClr val="FFE6DD"/>
+            <a:srgbClr val="DCE9FC"/>
           </a:solidFill>
           <a:ln w="19050" cap="flat" cmpd="sng" algn="ctr">
             <a:noFill/>
@@ -14031,11 +14039,11 @@
           </a:bodyPr>
           <a:lstStyle/>
           <a:p>
-            <a:pPr algn="l"/>
-            <a:r>
-              <a:rPr lang="en-US" sz="2200" b="1">
-                <a:solidFill>
-                  <a:srgbClr val="FF4F1F"/>
+            <a:pPr algn="ctr"/>
+            <a:r>
+              <a:rPr lang="en-US" sz="2200" b="1" dirty="0">
+                <a:solidFill>
+                  <a:srgbClr val="1F6FEB"/>
                 </a:solidFill>
               </a:rPr>
               <a:t>✕</a:t>
@@ -14200,7 +14208,7 @@
             <a:avLst/>
           </a:prstGeom>
           <a:solidFill>
-            <a:srgbClr val="FFE6DD"/>
+            <a:srgbClr val="DCE9FC"/>
           </a:solidFill>
           <a:ln w="19050" cap="flat" cmpd="sng" algn="ctr">
             <a:noFill/>
@@ -14230,11 +14238,11 @@
           </a:bodyPr>
           <a:lstStyle/>
           <a:p>
-            <a:pPr algn="l"/>
-            <a:r>
-              <a:rPr lang="en-US" sz="2200" b="1">
-                <a:solidFill>
-                  <a:srgbClr val="FF4F1F"/>
+            <a:pPr algn="ctr"/>
+            <a:r>
+              <a:rPr lang="en-US" sz="2200" b="1" dirty="0">
+                <a:solidFill>
+                  <a:srgbClr val="1F6FEB"/>
                 </a:solidFill>
               </a:rPr>
               <a:t>✕</a:t>
@@ -14399,7 +14407,7 @@
             <a:avLst/>
           </a:prstGeom>
           <a:solidFill>
-            <a:srgbClr val="FFE6DD"/>
+            <a:srgbClr val="DCE9FC"/>
           </a:solidFill>
           <a:ln w="19050" cap="flat" cmpd="sng" algn="ctr">
             <a:noFill/>
@@ -14429,11 +14437,11 @@
           </a:bodyPr>
           <a:lstStyle/>
           <a:p>
-            <a:pPr algn="l"/>
-            <a:r>
-              <a:rPr lang="en-US" sz="2200" b="1">
-                <a:solidFill>
-                  <a:srgbClr val="FF4F1F"/>
+            <a:pPr algn="ctr"/>
+            <a:r>
+              <a:rPr lang="en-US" sz="2200" b="1" dirty="0">
+                <a:solidFill>
+                  <a:srgbClr val="1F6FEB"/>
                 </a:solidFill>
               </a:rPr>
               <a:t>✕</a:t>
@@ -14606,7 +14614,7 @@
     </p:spTree>
     <p:extLst>
       <p:ext uri="{BB962C8B-B14F-4D97-AF65-F5344CB8AC3E}">
-        <p14:creationId xmlns:p14="http://schemas.microsoft.com/office/powerpoint/2010/main" val="2271782904"/>
+        <p14:creationId xmlns:p14="http://schemas.microsoft.com/office/powerpoint/2010/main" val="660189533"/>
       </p:ext>
     </p:extLst>
   </p:cSld>
@@ -14665,7 +14673,7 @@
             <a:r>
               <a:rPr lang="en-US" sz="1400" b="1">
                 <a:solidFill>
-                  <a:srgbClr val="FF4F1F"/>
+                  <a:srgbClr val="1F6FEB"/>
                 </a:solidFill>
               </a:rPr>
               <a:t>PART 05  ·  HANDS-ON  ·  10 MIN</a:t>
@@ -14730,7 +14738,7 @@
             <a:avLst/>
           </a:prstGeom>
           <a:solidFill>
-            <a:srgbClr val="FF4F1F"/>
+            <a:srgbClr val="1F6FEB"/>
           </a:solidFill>
           <a:ln w="19050" cap="flat" cmpd="sng" algn="ctr">
             <a:noFill/>
@@ -14869,7 +14877,7 @@
             <a:avLst/>
           </a:prstGeom>
           <a:solidFill>
-            <a:srgbClr val="FF4F1F"/>
+            <a:srgbClr val="1F6FEB"/>
           </a:solidFill>
           <a:ln w="19050" cap="flat" cmpd="sng" algn="ctr">
             <a:noFill/>
@@ -15008,7 +15016,7 @@
             <a:avLst/>
           </a:prstGeom>
           <a:solidFill>
-            <a:srgbClr val="FF4F1F"/>
+            <a:srgbClr val="1F6FEB"/>
           </a:solidFill>
           <a:ln w="19050" cap="flat" cmpd="sng" algn="ctr">
             <a:noFill/>
@@ -15147,7 +15155,7 @@
             <a:avLst/>
           </a:prstGeom>
           <a:solidFill>
-            <a:srgbClr val="FF4F1F"/>
+            <a:srgbClr val="1F6FEB"/>
           </a:solidFill>
           <a:ln w="19050" cap="flat" cmpd="sng" algn="ctr">
             <a:noFill/>
@@ -15286,7 +15294,7 @@
             <a:avLst/>
           </a:prstGeom>
           <a:solidFill>
-            <a:srgbClr val="FF4F1F"/>
+            <a:srgbClr val="1F6FEB"/>
           </a:solidFill>
           <a:ln w="19050" cap="flat" cmpd="sng" algn="ctr">
             <a:noFill/>
@@ -15407,7 +15415,7 @@
     </p:spTree>
     <p:extLst>
       <p:ext uri="{BB962C8B-B14F-4D97-AF65-F5344CB8AC3E}">
-        <p14:creationId xmlns:p14="http://schemas.microsoft.com/office/powerpoint/2010/main" val="1106861732"/>
+        <p14:creationId xmlns:p14="http://schemas.microsoft.com/office/powerpoint/2010/main" val="3646646175"/>
       </p:ext>
     </p:extLst>
   </p:cSld>
@@ -15520,7 +15528,7 @@
             <a:r>
               <a:rPr lang="en-US" sz="1600" b="1">
                 <a:solidFill>
-                  <a:srgbClr val="FF4F1F"/>
+                  <a:srgbClr val="1F6FEB"/>
                 </a:solidFill>
               </a:rPr>
               <a:t>Q&amp;A  ·  PART 06</a:t>
@@ -15640,7 +15648,7 @@
             <a:r>
               <a:rPr lang="en-US" sz="4000" b="1">
                 <a:solidFill>
-                  <a:srgbClr val="FF4F1F"/>
+                  <a:srgbClr val="1F6FEB"/>
                 </a:solidFill>
               </a:rPr>
               <a:t>Questions?</a:t>
@@ -15651,7 +15659,7 @@
     </p:spTree>
     <p:extLst>
       <p:ext uri="{BB962C8B-B14F-4D97-AF65-F5344CB8AC3E}">
-        <p14:creationId xmlns:p14="http://schemas.microsoft.com/office/powerpoint/2010/main" val="3573041247"/>
+        <p14:creationId xmlns:p14="http://schemas.microsoft.com/office/powerpoint/2010/main" val="4146637791"/>
       </p:ext>
     </p:extLst>
   </p:cSld>
@@ -15710,7 +15718,7 @@
             <a:r>
               <a:rPr lang="en-US" sz="1400" b="1" dirty="0">
                 <a:solidFill>
-                  <a:srgbClr val="FF4F1F"/>
+                  <a:srgbClr val="1F6FEB"/>
                 </a:solidFill>
               </a:rPr>
               <a:t>AGENDA  ·  60 MINUTES</a:t>
@@ -15929,7 +15937,7 @@
             <a:r>
               <a:rPr lang="en-US" sz="1600" b="1" dirty="0">
                 <a:solidFill>
-                  <a:srgbClr val="FF4F1F"/>
+                  <a:srgbClr val="1F6FEB"/>
                 </a:solidFill>
               </a:rPr>
               <a:t>5 min</a:t>
@@ -16112,7 +16120,7 @@
             <a:r>
               <a:rPr lang="en-US" sz="1600" b="1">
                 <a:solidFill>
-                  <a:srgbClr val="FF4F1F"/>
+                  <a:srgbClr val="1F6FEB"/>
                 </a:solidFill>
               </a:rPr>
               <a:t>8 min</a:t>
@@ -16295,7 +16303,7 @@
             <a:r>
               <a:rPr lang="en-US" sz="1600" b="1">
                 <a:solidFill>
-                  <a:srgbClr val="FF4F1F"/>
+                  <a:srgbClr val="1F6FEB"/>
                 </a:solidFill>
               </a:rPr>
               <a:t>12 min</a:t>
@@ -16478,7 +16486,7 @@
             <a:r>
               <a:rPr lang="en-US" sz="1600" b="1">
                 <a:solidFill>
-                  <a:srgbClr val="FF4F1F"/>
+                  <a:srgbClr val="1F6FEB"/>
                 </a:solidFill>
               </a:rPr>
               <a:t>17 min</a:t>
@@ -16661,7 +16669,7 @@
             <a:r>
               <a:rPr lang="en-US" sz="1600" b="1">
                 <a:solidFill>
-                  <a:srgbClr val="FF4F1F"/>
+                  <a:srgbClr val="1F6FEB"/>
                 </a:solidFill>
               </a:rPr>
               <a:t>10 min</a:t>
@@ -16844,7 +16852,7 @@
             <a:r>
               <a:rPr lang="en-US" sz="1600" b="1">
                 <a:solidFill>
-                  <a:srgbClr val="FF4F1F"/>
+                  <a:srgbClr val="1F6FEB"/>
                 </a:solidFill>
               </a:rPr>
               <a:t>8 min</a:t>
@@ -16895,7 +16903,7 @@
     </p:spTree>
     <p:extLst>
       <p:ext uri="{BB962C8B-B14F-4D97-AF65-F5344CB8AC3E}">
-        <p14:creationId xmlns:p14="http://schemas.microsoft.com/office/powerpoint/2010/main" val="3510166236"/>
+        <p14:creationId xmlns:p14="http://schemas.microsoft.com/office/powerpoint/2010/main" val="41705548"/>
       </p:ext>
     </p:extLst>
   </p:cSld>
@@ -16954,7 +16962,7 @@
             <a:r>
               <a:rPr lang="en-US" sz="1400" b="1">
                 <a:solidFill>
-                  <a:srgbClr val="FF4F1F"/>
+                  <a:srgbClr val="1F6FEB"/>
                 </a:solidFill>
               </a:rPr>
               <a:t>PART 01  ·  AUDIENCE CHECK</a:t>
@@ -17079,7 +17087,7 @@
             <a:avLst/>
           </a:prstGeom>
           <a:solidFill>
-            <a:srgbClr val="0E1116"/>
+            <a:schemeClr val="tx1"/>
           </a:solidFill>
           <a:ln w="19050" cap="flat" cmpd="sng" algn="ctr">
             <a:noFill/>
@@ -17269,7 +17277,7 @@
             <a:avLst/>
           </a:prstGeom>
           <a:solidFill>
-            <a:srgbClr val="1F6FEB"/>
+            <a:schemeClr val="tx1"/>
           </a:solidFill>
           <a:ln w="19050" cap="flat" cmpd="sng" algn="ctr">
             <a:noFill/>
@@ -17459,7 +17467,7 @@
             <a:avLst/>
           </a:prstGeom>
           <a:solidFill>
-            <a:srgbClr val="FF4F1F"/>
+            <a:schemeClr val="tx1"/>
           </a:solidFill>
           <a:ln w="19050" cap="flat" cmpd="sng" algn="ctr">
             <a:noFill/>
@@ -17712,12 +17720,12 @@
           <a:p>
             <a:pPr algn="l"/>
             <a:r>
-              <a:rPr lang="en-US" sz="2200" b="1">
+              <a:rPr lang="en-US" sz="2200" b="1" dirty="0">
                 <a:solidFill>
                   <a:srgbClr val="0E1116"/>
                 </a:solidFill>
               </a:rPr>
-              <a:t>Never used an AI coding tool</a:t>
+              <a:t>Antigravity</a:t>
             </a:r>
           </a:p>
         </p:txBody>
@@ -17805,7 +17813,7 @@
     </p:spTree>
     <p:extLst>
       <p:ext uri="{BB962C8B-B14F-4D97-AF65-F5344CB8AC3E}">
-        <p14:creationId xmlns:p14="http://schemas.microsoft.com/office/powerpoint/2010/main" val="3191818140"/>
+        <p14:creationId xmlns:p14="http://schemas.microsoft.com/office/powerpoint/2010/main" val="2091753748"/>
       </p:ext>
     </p:extLst>
   </p:cSld>
@@ -17918,7 +17926,7 @@
             <a:r>
               <a:rPr lang="en-US" sz="1600" b="1">
                 <a:solidFill>
-                  <a:srgbClr val="FF4F1F"/>
+                  <a:srgbClr val="1F6FEB"/>
                 </a:solidFill>
               </a:rPr>
               <a:t>THE ONE IDEA</a:t>
@@ -18049,7 +18057,7 @@
     </p:spTree>
     <p:extLst>
       <p:ext uri="{BB962C8B-B14F-4D97-AF65-F5344CB8AC3E}">
-        <p14:creationId xmlns:p14="http://schemas.microsoft.com/office/powerpoint/2010/main" val="3402902732"/>
+        <p14:creationId xmlns:p14="http://schemas.microsoft.com/office/powerpoint/2010/main" val="1002178939"/>
       </p:ext>
     </p:extLst>
   </p:cSld>
@@ -18108,7 +18116,7 @@
             <a:r>
               <a:rPr lang="en-US" sz="1400" b="1">
                 <a:solidFill>
-                  <a:srgbClr val="FF4F1F"/>
+                  <a:srgbClr val="1F6FEB"/>
                 </a:solidFill>
               </a:rPr>
               <a:t>THE SPINE OF THE TALK</a:t>
@@ -18184,7 +18192,7 @@
             <a:r>
               <a:rPr lang="en-US" sz="3600" b="1">
                 <a:solidFill>
-                  <a:srgbClr val="FF4F1F"/>
+                  <a:srgbClr val="1F6FEB"/>
                 </a:solidFill>
               </a:rPr>
               <a:t>01</a:t>
@@ -18300,7 +18308,7 @@
             <a:r>
               <a:rPr lang="en-US" sz="3600" b="1">
                 <a:solidFill>
-                  <a:srgbClr val="FF4F1F"/>
+                  <a:srgbClr val="1F6FEB"/>
                 </a:solidFill>
               </a:rPr>
               <a:t>02</a:t>
@@ -18416,7 +18424,7 @@
             <a:r>
               <a:rPr lang="en-US" sz="3600" b="1">
                 <a:solidFill>
-                  <a:srgbClr val="FF4F1F"/>
+                  <a:srgbClr val="1F6FEB"/>
                 </a:solidFill>
               </a:rPr>
               <a:t>03</a:t>
@@ -18544,7 +18552,7 @@
             <a:r>
               <a:rPr lang="en-US" sz="3600" b="1">
                 <a:solidFill>
-                  <a:srgbClr val="FF4F1F"/>
+                  <a:srgbClr val="1F6FEB"/>
                 </a:solidFill>
               </a:rPr>
               <a:t>04</a:t>
@@ -18660,7 +18668,7 @@
             <a:r>
               <a:rPr lang="en-US" sz="3600" b="1">
                 <a:solidFill>
-                  <a:srgbClr val="FF4F1F"/>
+                  <a:srgbClr val="1F6FEB"/>
                 </a:solidFill>
               </a:rPr>
               <a:t>05</a:t>
@@ -18787,7 +18795,7 @@
     </p:spTree>
     <p:extLst>
       <p:ext uri="{BB962C8B-B14F-4D97-AF65-F5344CB8AC3E}">
-        <p14:creationId xmlns:p14="http://schemas.microsoft.com/office/powerpoint/2010/main" val="2104548840"/>
+        <p14:creationId xmlns:p14="http://schemas.microsoft.com/office/powerpoint/2010/main" val="2205879928"/>
       </p:ext>
     </p:extLst>
   </p:cSld>
@@ -18846,7 +18854,7 @@
             <a:r>
               <a:rPr lang="en-US" sz="20000" b="1">
                 <a:solidFill>
-                  <a:srgbClr val="FF4F1F"/>
+                  <a:srgbClr val="1F6FEB"/>
                 </a:solidFill>
               </a:rPr>
               <a:t>02</a:t>
@@ -18886,7 +18894,7 @@
             <a:r>
               <a:rPr lang="en-US" sz="1600" b="1">
                 <a:solidFill>
-                  <a:srgbClr val="FF4F1F"/>
+                  <a:srgbClr val="1F6FEB"/>
                 </a:solidFill>
               </a:rPr>
               <a:t>PART 02  ·  8 MIN</a:t>
@@ -18973,7 +18981,7 @@
     </p:spTree>
     <p:extLst>
       <p:ext uri="{BB962C8B-B14F-4D97-AF65-F5344CB8AC3E}">
-        <p14:creationId xmlns:p14="http://schemas.microsoft.com/office/powerpoint/2010/main" val="783946156"/>
+        <p14:creationId xmlns:p14="http://schemas.microsoft.com/office/powerpoint/2010/main" val="468119430"/>
       </p:ext>
     </p:extLst>
   </p:cSld>
@@ -19032,7 +19040,7 @@
             <a:r>
               <a:rPr lang="en-US" sz="1400" b="1">
                 <a:solidFill>
-                  <a:srgbClr val="FF4F1F"/>
+                  <a:srgbClr val="1F6FEB"/>
                 </a:solidFill>
               </a:rPr>
               <a:t>FOUR HABITS</a:t>
@@ -19164,7 +19172,7 @@
             <a:r>
               <a:rPr lang="en-US" sz="1300" b="1">
                 <a:solidFill>
-                  <a:srgbClr val="FF4F1F"/>
+                  <a:srgbClr val="1F6FEB"/>
                 </a:solidFill>
               </a:rPr>
               <a:t>01</a:t>
@@ -19336,7 +19344,7 @@
             <a:r>
               <a:rPr lang="en-US" sz="1300" b="1">
                 <a:solidFill>
-                  <a:srgbClr val="FF4F1F"/>
+                  <a:srgbClr val="1F6FEB"/>
                 </a:solidFill>
               </a:rPr>
               <a:t>02</a:t>
@@ -19508,7 +19516,7 @@
             <a:r>
               <a:rPr lang="en-US" sz="1300" b="1">
                 <a:solidFill>
-                  <a:srgbClr val="FF4F1F"/>
+                  <a:srgbClr val="1F6FEB"/>
                 </a:solidFill>
               </a:rPr>
               <a:t>03</a:t>
@@ -19680,7 +19688,7 @@
             <a:r>
               <a:rPr lang="en-US" sz="1300" b="1">
                 <a:solidFill>
-                  <a:srgbClr val="FF4F1F"/>
+                  <a:srgbClr val="1F6FEB"/>
                 </a:solidFill>
               </a:rPr>
               <a:t>04</a:t>
@@ -19870,7 +19878,7 @@
     </p:spTree>
     <p:extLst>
       <p:ext uri="{BB962C8B-B14F-4D97-AF65-F5344CB8AC3E}">
-        <p14:creationId xmlns:p14="http://schemas.microsoft.com/office/powerpoint/2010/main" val="1073423912"/>
+        <p14:creationId xmlns:p14="http://schemas.microsoft.com/office/powerpoint/2010/main" val="3972119432"/>
       </p:ext>
     </p:extLst>
   </p:cSld>
@@ -19929,7 +19937,7 @@
             <a:r>
               <a:rPr lang="en-US" sz="20000" b="1">
                 <a:solidFill>
-                  <a:srgbClr val="FF4F1F"/>
+                  <a:srgbClr val="1F6FEB"/>
                 </a:solidFill>
               </a:rPr>
               <a:t>03</a:t>
@@ -19969,7 +19977,7 @@
             <a:r>
               <a:rPr lang="en-US" sz="1600" b="1">
                 <a:solidFill>
-                  <a:srgbClr val="FF4F1F"/>
+                  <a:srgbClr val="1F6FEB"/>
                 </a:solidFill>
               </a:rPr>
               <a:t>PART 03  ·  12 MIN</a:t>
@@ -20056,7 +20064,7 @@
     </p:spTree>
     <p:extLst>
       <p:ext uri="{BB962C8B-B14F-4D97-AF65-F5344CB8AC3E}">
-        <p14:creationId xmlns:p14="http://schemas.microsoft.com/office/powerpoint/2010/main" val="2649299340"/>
+        <p14:creationId xmlns:p14="http://schemas.microsoft.com/office/powerpoint/2010/main" val="4205335575"/>
       </p:ext>
     </p:extLst>
   </p:cSld>
@@ -20067,7 +20075,7 @@
 </file>
 
 <file path=ppt/theme/theme1.xml><?xml version="1.0" encoding="utf-8"?>
-<a:theme xmlns:a="http://schemas.openxmlformats.org/drawingml/2006/main" name="Office Theme [1778283979305]">
+<a:theme xmlns:a="http://schemas.openxmlformats.org/drawingml/2006/main" name="Office Theme [1778333085324]">
   <a:themeElements>
     <a:clrScheme name="Office">
       <a:dk1>
@@ -20083,7 +20091,7 @@
         <a:srgbClr val="E5E7EB"/>
       </a:lt2>
       <a:accent1>
-        <a:srgbClr val="FF4F1F"/>
+        <a:srgbClr val="1F6FEB"/>
       </a:accent1>
       <a:accent2>
         <a:srgbClr val="1F6FEB"/>

</xml_diff>